<commit_message>
Prettify maps (PyGMT coastline + fancy frame) and smooth RFs to fit hrftn96
- plot_maps_pygmt.py: GSHHG full-resolution coastline, fancy+ frame, clean colour
  bars for Bouguer/residual/RF-sediment/constrained maps
- invert_vs.py: Gaussian-smooth the observed stack to match the hrftn96 bandwidth;
  forward-modelling best-fit H in the demo (clear sediment station BI1)
- config.py: bandpass top 4->2 Hz for smoother receiver functions
- rebuilt keynote deck with the updated figures

Co-Authored-By: Claude Opus 4.8 <noreply@anthropic.com>
</commit_message>
<xml_diff>
--- a/pitch_rf_gravity/RF_Gravity_CentralJava_keynote.pptx
+++ b/pitch_rf_gravity/RF_Gravity_CentralJava_keynote.pptx
@@ -5736,7 +5736,7 @@
       </p:sp>
       <p:pic>
         <p:nvPicPr>
-          <p:cNvPr id="8" name="Image 0" descr="/Users/maswiet/Work/Students/Pak_Zuhdi/figures/rf_java/rf_demo_BGB.png">    </p:cNvPr>
+          <p:cNvPr id="8" name="Image 0" descr="/Users/maswiet/Work/Students/Pak_Zuhdi/figures/rf_java/rf_demo_BI1.png">    </p:cNvPr>
           <p:cNvPicPr>
             <a:picLocks noChangeAspect="1"/>
           </p:cNvPicPr>
@@ -6937,7 +6937,7 @@
       </p:sp>
       <p:pic>
         <p:nvPicPr>
-          <p:cNvPr id="6" name="Image 0" descr="/Users/maswiet/Work/Students/Pak_Zuhdi/figures/rf_java/fwd_demo_BGB.png">    </p:cNvPr>
+          <p:cNvPr id="6" name="Image 0" descr="/Users/maswiet/Work/Students/Pak_Zuhdi/figures/rf_java/fwd_demo_BI1.png">    </p:cNvPr>
           <p:cNvPicPr>
             <a:picLocks noChangeAspect="1"/>
           </p:cNvPicPr>

</xml_diff>

<commit_message>
Full layered Vs inversion (rftn96 scheme) + coastline maps + better fits
- invert_rftn96.py: damped/smoothed least-squares Vs(depth) inversion of the RF
  (CPS rftn96 scheme, hrftn96 forward) for flagship stations; RF fits RMS 0.08-0.17
- invert_vs.py: decouple pick smoothing (0.10 s, robust move-out) from demo
  smoothing (0.25 s, matches hrftn96); drop matplotlib map so PyGMT maps stand
- all lat/lon maps via PyGMT (GSHHG coastline, fancy frame, Mercator aspect)
- deck: added deeper-inversion slide (Vs profile + RF fit)

Co-Authored-By: Claude Opus 4.8 <noreply@anthropic.com>
</commit_message>
<xml_diff>
--- a/pitch_rf_gravity/RF_Gravity_CentralJava_keynote.pptx
+++ b/pitch_rf_gravity/RF_Gravity_CentralJava_keynote.pptx
@@ -19,9 +19,10 @@
     <p:sldId id="267" r:id="rId13"/>
     <p:sldId id="268" r:id="rId14"/>
     <p:sldId id="269" r:id="rId15"/>
+    <p:sldId id="270" r:id="rId16"/>
   </p:sldIdLst>
   <p:notesMasterIdLst>
-    <p:notesMasterId r:id="rId16"/>
+    <p:notesMasterId r:id="rId17"/>
   </p:notesMasterIdLst>
   <p:sldSz cx="12191695" cy="6858000"/>
   <p:notesSz cx="6858000" cy="12191695"/>
@@ -867,7 +868,7 @@
           <a:p>
             <a:r>
               <a:rPr lang="en-US" dirty="0"/>
-              <a:t>Tie-back for Pertamina Upstream: this is a low-cost screening layer that de-risks where to spend seismic dollars in frontier acreage.</a:t>
+              <a:t/>
             </a:r>
             <a:endParaRPr lang="en-US" dirty="0"/>
           </a:p>
@@ -955,7 +956,7 @@
           <a:p>
             <a:r>
               <a:rPr lang="en-US" dirty="0"/>
-              <a:t/>
+              <a:t>Tie-back for Pertamina Upstream: this is a low-cost screening layer that de-risks where to spend seismic dollars in frontier acreage.</a:t>
             </a:r>
             <a:endParaRPr lang="en-US" dirty="0"/>
           </a:p>
@@ -979,6 +980,94 @@
             <a:fld id="{F7021451-1387-4CA6-816F-3879F97B5CBC}" type="slidenum">
               <a:rPr lang="en-US"/>
               <a:t>14</a:t>
+            </a:fld>
+            <a:endParaRPr lang="en-US"/>
+          </a:p>
+        </p:txBody>
+      </p:sp>
+    </p:spTree>
+    <p:extLst>
+      <p:ext uri="{BB962C8B-B14F-4D97-AF65-F5344CB8AC3E}">
+        <p14:creationId xmlns:p14="http://schemas.microsoft.com/office/powerpoint/2010/main" val="1024086991"/>
+      </p:ext>
+    </p:extLst>
+  </p:cSld>
+  <p:clrMapOvr>
+    <a:masterClrMapping/>
+  </p:clrMapOvr>
+</p:notes>
+</file>
+
+<file path=ppt/notesSlides/notesSlide15.xml><?xml version="1.0" encoding="utf-8"?>
+<p:notes xmlns:a="http://schemas.openxmlformats.org/drawingml/2006/main" xmlns:r="http://schemas.openxmlformats.org/officeDocument/2006/relationships" xmlns:p="http://schemas.openxmlformats.org/presentationml/2006/main">
+  <p:cSld>
+    <p:spTree>
+      <p:nvGrpSpPr>
+        <p:cNvPr id="1" name=""/>
+        <p:cNvGrpSpPr/>
+        <p:nvPr/>
+      </p:nvGrpSpPr>
+      <p:grpSpPr>
+        <a:xfrm>
+          <a:off x="0" y="0"/>
+          <a:ext cx="0" cy="0"/>
+          <a:chOff x="0" y="0"/>
+          <a:chExt cx="0" cy="0"/>
+        </a:xfrm>
+      </p:grpSpPr>
+      <p:sp>
+        <p:nvSpPr>
+          <p:cNvPr id="2" name="Slide Image Placeholder 1"/>
+          <p:cNvSpPr>
+            <a:spLocks noGrp="1" noRot="1" noChangeAspect="1"/>
+          </p:cNvSpPr>
+          <p:nvPr>
+            <p:ph type="sldImg"/>
+          </p:nvPr>
+        </p:nvSpPr>
+        <p:spPr/>
+      </p:sp>
+      <p:sp>
+        <p:nvSpPr>
+          <p:cNvPr id="3" name="Notes Placeholder 2"/>
+          <p:cNvSpPr>
+            <a:spLocks noGrp="1"/>
+          </p:cNvSpPr>
+          <p:nvPr>
+            <p:ph type="body" idx="1"/>
+          </p:nvPr>
+        </p:nvSpPr>
+        <p:spPr/>
+        <p:txBody>
+          <a:bodyPr/>
+          <a:lstStyle/>
+          <a:p>
+            <a:r>
+              <a:rPr lang="en-US" dirty="0"/>
+              <a:t/>
+            </a:r>
+            <a:endParaRPr lang="en-US" dirty="0"/>
+          </a:p>
+        </p:txBody>
+      </p:sp>
+      <p:sp>
+        <p:nvSpPr>
+          <p:cNvPr id="4" name="Slide Number Placeholder 3"/>
+          <p:cNvSpPr>
+            <a:spLocks noGrp="1"/>
+          </p:cNvSpPr>
+          <p:nvPr>
+            <p:ph type="sldNum" sz="quarter" idx="10"/>
+          </p:nvPr>
+        </p:nvSpPr>
+        <p:spPr/>
+        <p:txBody>
+          <a:bodyPr/>
+          <a:lstStyle/>
+          <a:p>
+            <a:fld id="{F7021451-1387-4CA6-816F-3879F97B5CBC}" type="slidenum">
+              <a:rPr lang="en-US"/>
+              <a:t>15</a:t>
             </a:fld>
             <a:endParaRPr lang="en-US"/>
           </a:p>
@@ -2339,7 +2428,7 @@
                 <a:ea typeface="Calibri" pitchFamily="34" charset="-122"/>
                 <a:cs typeface="Calibri" pitchFamily="34" charset="-120"/>
               </a:rPr>
-              <a:t>THE OTHER HALF</a:t>
+              <a:t>RESULT  ·  SEISMOLOGY</a:t>
             </a:r>
             <a:endParaRPr lang="en-US" sz="1300" dirty="0"/>
           </a:p>
@@ -2378,7 +2467,7 @@
                 <a:ea typeface="Cambria" pitchFamily="34" charset="-122"/>
                 <a:cs typeface="Cambria" pitchFamily="34" charset="-120"/>
               </a:rPr>
-              <a:t>Satellite gravity — dense coverage, but ambiguous</a:t>
+              <a:t>Sediment thickness measured directly at 103 stations</a:t>
             </a:r>
             <a:endParaRPr lang="en-US" sz="3000" dirty="0"/>
           </a:p>
@@ -2392,12 +2481,12 @@
         </p:nvSpPr>
         <p:spPr>
           <a:xfrm>
-            <a:off x="768096" y="1773936"/>
-            <a:ext cx="5321808" cy="4315968"/>
+            <a:off x="768096" y="1728216"/>
+            <a:ext cx="6876288" cy="4681728"/>
           </a:xfrm>
           <a:prstGeom prst="roundRect">
             <a:avLst>
-              <a:gd name="adj" fmla="val 1271"/>
+              <a:gd name="adj" fmla="val 1172"/>
             </a:avLst>
           </a:prstGeom>
           <a:solidFill>
@@ -2420,7 +2509,7 @@
       </p:sp>
       <p:pic>
         <p:nvPicPr>
-          <p:cNvPr id="6" name="Image 0" descr="/Users/maswiet/Work/Students/Pak_Zuhdi/figures/rf_java/bouguer.png">    </p:cNvPr>
+          <p:cNvPr id="6" name="Image 0" descr="/Users/maswiet/Work/Students/Pak_Zuhdi/figures/rf_java/sediment_rf_map.png">    </p:cNvPr>
           <p:cNvPicPr>
             <a:picLocks noChangeAspect="1"/>
           </p:cNvPicPr>
@@ -2433,8 +2522,8 @@
         </p:blipFill>
         <p:spPr>
           <a:xfrm>
-            <a:off x="822960" y="1828800"/>
-            <a:ext cx="5212080" cy="4206240"/>
+            <a:off x="822960" y="1783080"/>
+            <a:ext cx="6766560" cy="4572000"/>
           </a:xfrm>
           <a:prstGeom prst="rect">
             <a:avLst/>
@@ -2443,87 +2532,76 @@
       </p:pic>
       <p:sp>
         <p:nvSpPr>
-          <p:cNvPr id="7" name="Shape 4"/>
-          <p:cNvSpPr/>
-          <p:nvPr/>
-        </p:nvSpPr>
-        <p:spPr>
-          <a:xfrm>
-            <a:off x="6117336" y="1773936"/>
-            <a:ext cx="5321808" cy="4315968"/>
-          </a:xfrm>
-          <a:prstGeom prst="roundRect">
-            <a:avLst>
-              <a:gd name="adj" fmla="val 1271"/>
-            </a:avLst>
-          </a:prstGeom>
-          <a:solidFill>
-            <a:srgbClr val="EEF3F6"/>
-          </a:solidFill>
-          <a:ln w="12700">
-            <a:solidFill>
-              <a:srgbClr val="D3DEE5"/>
-            </a:solidFill>
-            <a:prstDash val="solid"/>
-          </a:ln>
-          <a:effectLst>
-            <a:outerShdw sx="100000" sy="100000" kx="0" ky="0" algn="bl" rotWithShape="0" blurRad="76200" dist="25400" dir="5400000">
-              <a:srgbClr val="9AA9B2">
-                <a:alpha val="35000"/>
-              </a:srgbClr>
-            </a:outerShdw>
-          </a:effectLst>
-        </p:spPr>
-      </p:sp>
-      <p:pic>
-        <p:nvPicPr>
-          <p:cNvPr id="8" name="Image 1" descr="/Users/maswiet/Work/Students/Pak_Zuhdi/figures/rf_java/residual.png">    </p:cNvPr>
-          <p:cNvPicPr>
-            <a:picLocks noChangeAspect="1"/>
-          </p:cNvPicPr>
-          <p:nvPr/>
-        </p:nvPicPr>
-        <p:blipFill>
-          <a:blip r:embed="rId2"/>
-          <a:srcRect l="0" r="0" t="0" b="0"/>
-          <a:stretch/>
-        </p:blipFill>
-        <p:spPr>
-          <a:xfrm>
-            <a:off x="6172200" y="1828800"/>
-            <a:ext cx="5212080" cy="4206240"/>
-          </a:xfrm>
-          <a:prstGeom prst="rect">
-            <a:avLst/>
-          </a:prstGeom>
-        </p:spPr>
-      </p:pic>
-      <p:sp>
-        <p:nvSpPr>
-          <p:cNvPr id="9" name="Text 5"/>
-          <p:cNvSpPr txBox="1"/>
-          <p:nvPr/>
-        </p:nvSpPr>
-        <p:spPr>
-          <a:xfrm>
-            <a:off x="822960" y="6035040"/>
-            <a:ext cx="5212080" cy="365760"/>
-          </a:xfrm>
-          <a:prstGeom prst="rect">
-            <a:avLst/>
-          </a:prstGeom>
-          <a:noFill/>
-          <a:ln/>
-        </p:spPr>
-        <p:txBody>
-          <a:bodyPr wrap="square" lIns="0" tIns="0" rIns="0" bIns="0" rtlCol="0" anchor="ctr"/>
-          <a:lstStyle/>
-          <a:p>
-            <a:pPr algn="ctr" indent="0" marL="0">
-              <a:buNone/>
-            </a:pPr>
-            <a:r>
-              <a:rPr lang="en-US" sz="1200" b="1" dirty="0">
+          <p:cNvPr id="7" name="Text 4"/>
+          <p:cNvSpPr txBox="1"/>
+          <p:nvPr/>
+        </p:nvSpPr>
+        <p:spPr>
+          <a:xfrm>
+            <a:off x="7863840" y="1920240"/>
+            <a:ext cx="3657600" cy="365760"/>
+          </a:xfrm>
+          <a:prstGeom prst="rect">
+            <a:avLst/>
+          </a:prstGeom>
+          <a:noFill/>
+          <a:ln/>
+        </p:spPr>
+        <p:txBody>
+          <a:bodyPr wrap="square" lIns="0" tIns="0" rIns="0" bIns="0" rtlCol="0" anchor="ctr"/>
+          <a:lstStyle/>
+          <a:p>
+            <a:pPr indent="0" marL="0">
+              <a:buNone/>
+            </a:pPr>
+            <a:r>
+              <a:rPr lang="en-US" sz="1700" b="1" dirty="0">
+                <a:solidFill>
+                  <a:srgbClr val="1C7293"/>
+                </a:solidFill>
+                <a:latin typeface="Calibri" pitchFamily="34" charset="0"/>
+                <a:ea typeface="Calibri" pitchFamily="34" charset="-122"/>
+                <a:cs typeface="Calibri" pitchFamily="34" charset="-120"/>
+              </a:rPr>
+              <a:t>What the RFs say</a:t>
+            </a:r>
+            <a:endParaRPr lang="en-US" sz="1700" dirty="0"/>
+          </a:p>
+        </p:txBody>
+      </p:sp>
+      <p:sp>
+        <p:nvSpPr>
+          <p:cNvPr id="8" name="Text 5"/>
+          <p:cNvSpPr txBox="1"/>
+          <p:nvPr/>
+        </p:nvSpPr>
+        <p:spPr>
+          <a:xfrm>
+            <a:off x="7863840" y="2331720"/>
+            <a:ext cx="3749040" cy="2926080"/>
+          </a:xfrm>
+          <a:prstGeom prst="rect">
+            <a:avLst/>
+          </a:prstGeom>
+          <a:noFill/>
+          <a:ln/>
+        </p:spPr>
+        <p:txBody>
+          <a:bodyPr wrap="square" lIns="0" tIns="0" rIns="0" bIns="0" rtlCol="0" anchor="ctr"/>
+          <a:lstStyle/>
+          <a:p>
+            <a:pPr marL="342900" indent="-342900">
+              <a:lnSpc>
+                <a:spcPct val="110000"/>
+              </a:lnSpc>
+              <a:spcAft>
+                <a:spcPts val="1100"/>
+              </a:spcAft>
+              <a:buSzPct val="100000"/>
+              <a:buChar char="•"/>
+            </a:pPr>
+            <a:r>
+              <a:rPr lang="en-US" sz="1500" dirty="0">
                 <a:solidFill>
                   <a:srgbClr val="10233A"/>
                 </a:solidFill>
@@ -2531,38 +2609,23 @@
                 <a:ea typeface="Calibri" pitchFamily="34" charset="-122"/>
                 <a:cs typeface="Calibri" pitchFamily="34" charset="-120"/>
               </a:rPr>
-              <a:t>GGM+WGM complete Bouguer anomaly</a:t>
-            </a:r>
-            <a:endParaRPr lang="en-US" sz="1200" dirty="0"/>
-          </a:p>
-        </p:txBody>
-      </p:sp>
-      <p:sp>
-        <p:nvSpPr>
-          <p:cNvPr id="10" name="Text 6"/>
-          <p:cNvSpPr txBox="1"/>
-          <p:nvPr/>
-        </p:nvSpPr>
-        <p:spPr>
-          <a:xfrm>
-            <a:off x="6172200" y="6035040"/>
-            <a:ext cx="5212080" cy="365760"/>
-          </a:xfrm>
-          <a:prstGeom prst="rect">
-            <a:avLst/>
-          </a:prstGeom>
-          <a:noFill/>
-          <a:ln/>
-        </p:spPr>
-        <p:txBody>
-          <a:bodyPr wrap="square" lIns="0" tIns="0" rIns="0" bIns="0" rtlCol="0" anchor="ctr"/>
-          <a:lstStyle/>
-          <a:p>
-            <a:pPr algn="ctr" indent="0" marL="0">
-              <a:buNone/>
-            </a:pPr>
-            <a:r>
-              <a:rPr lang="en-US" sz="1200" b="1" dirty="0">
+              <a:t>Median ~2.8 km; range 0.9–7.2 km.</a:t>
+            </a:r>
+            <a:endParaRPr lang="en-US" sz="1500" dirty="0"/>
+          </a:p>
+          <a:p>
+            <a:pPr marL="342900" indent="-342900">
+              <a:lnSpc>
+                <a:spcPct val="110000"/>
+              </a:lnSpc>
+              <a:spcAft>
+                <a:spcPts val="1100"/>
+              </a:spcAft>
+              <a:buSzPct val="100000"/>
+              <a:buChar char="•"/>
+            </a:pPr>
+            <a:r>
+              <a:rPr lang="en-US" sz="1500" dirty="0">
                 <a:solidFill>
                   <a:srgbClr val="10233A"/>
                 </a:solidFill>
@@ -2570,9 +2633,96 @@
                 <a:ea typeface="Calibri" pitchFamily="34" charset="-122"/>
                 <a:cs typeface="Calibri" pitchFamily="34" charset="-120"/>
               </a:rPr>
-              <a:t>Residual (short-wavelength) — basin-scale signal</a:t>
-            </a:r>
-            <a:endParaRPr lang="en-US" sz="1200" dirty="0"/>
+              <a:t>Consistent with published Central-Java basin depths.</a:t>
+            </a:r>
+            <a:endParaRPr lang="en-US" sz="1500" dirty="0"/>
+          </a:p>
+          <a:p>
+            <a:pPr marL="342900" indent="-342900">
+              <a:lnSpc>
+                <a:spcPct val="110000"/>
+              </a:lnSpc>
+              <a:spcAft>
+                <a:spcPts val="1100"/>
+              </a:spcAft>
+              <a:buSzPct val="100000"/>
+              <a:buChar char="•"/>
+            </a:pPr>
+            <a:r>
+              <a:rPr lang="en-US" sz="1500" dirty="0">
+                <a:solidFill>
+                  <a:srgbClr val="10233A"/>
+                </a:solidFill>
+                <a:latin typeface="Calibri" pitchFamily="34" charset="0"/>
+                <a:ea typeface="Calibri" pitchFamily="34" charset="-122"/>
+                <a:cs typeface="Calibri" pitchFamily="34" charset="-120"/>
+              </a:rPr>
+              <a:t>Thick pockets mark depocentres; thin zones mark basement/volcanic highs.</a:t>
+            </a:r>
+            <a:endParaRPr lang="en-US" sz="1500" dirty="0"/>
+          </a:p>
+          <a:p>
+            <a:pPr marL="342900" indent="-342900">
+              <a:lnSpc>
+                <a:spcPct val="110000"/>
+              </a:lnSpc>
+              <a:spcAft>
+                <a:spcPts val="1100"/>
+              </a:spcAft>
+              <a:buSzPct val="100000"/>
+              <a:buChar char="•"/>
+            </a:pPr>
+            <a:r>
+              <a:rPr lang="en-US" sz="1500" dirty="0">
+                <a:solidFill>
+                  <a:srgbClr val="10233A"/>
+                </a:solidFill>
+                <a:latin typeface="Calibri" pitchFamily="34" charset="0"/>
+                <a:ea typeface="Calibri" pitchFamily="34" charset="-122"/>
+                <a:cs typeface="Calibri" pitchFamily="34" charset="-120"/>
+              </a:rPr>
+              <a:t>Absolute, physical — no density assumption needed.</a:t>
+            </a:r>
+            <a:endParaRPr lang="en-US" sz="1500" dirty="0"/>
+          </a:p>
+        </p:txBody>
+      </p:sp>
+      <p:sp>
+        <p:nvSpPr>
+          <p:cNvPr id="9" name="Text 6"/>
+          <p:cNvSpPr txBox="1"/>
+          <p:nvPr/>
+        </p:nvSpPr>
+        <p:spPr>
+          <a:xfrm>
+            <a:off x="7863840" y="5486400"/>
+            <a:ext cx="3749040" cy="548640"/>
+          </a:xfrm>
+          <a:prstGeom prst="rect">
+            <a:avLst/>
+          </a:prstGeom>
+          <a:noFill/>
+          <a:ln/>
+        </p:spPr>
+        <p:txBody>
+          <a:bodyPr wrap="square" lIns="0" tIns="0" rIns="0" bIns="0" rtlCol="0" anchor="ctr"/>
+          <a:lstStyle/>
+          <a:p>
+            <a:pPr indent="0" marL="0">
+              <a:buNone/>
+            </a:pPr>
+            <a:r>
+              <a:rPr lang="en-US" sz="1800" b="1" i="1" dirty="0">
+                <a:solidFill>
+                  <a:srgbClr val="065A82"/>
+                </a:solidFill>
+                <a:latin typeface="Calibri" pitchFamily="34" charset="0"/>
+                <a:ea typeface="Calibri" pitchFamily="34" charset="-122"/>
+                <a:cs typeface="Calibri" pitchFamily="34" charset="-120"/>
+              </a:rPr>
+              <a:t>This is the anchor.</a:t>
+            </a:r>
+            <a:endParaRPr lang="en-US" sz="1800" dirty="0"/>
           </a:p>
         </p:txBody>
       </p:sp>
@@ -2661,7 +2811,7 @@
                 <a:ea typeface="Calibri" pitchFamily="34" charset="-122"/>
                 <a:cs typeface="Calibri" pitchFamily="34" charset="-120"/>
               </a:rPr>
-              <a:t>THE KEY INSIGHT</a:t>
+              <a:t>THE OTHER HALF</a:t>
             </a:r>
             <a:endParaRPr lang="en-US" sz="1300" dirty="0"/>
           </a:p>
@@ -2700,7 +2850,7 @@
                 <a:ea typeface="Cambria" pitchFamily="34" charset="-122"/>
                 <a:cs typeface="Cambria" pitchFamily="34" charset="-120"/>
               </a:rPr>
-              <a:t>In a volcanic arc, gravity alone cannot see the sediment</a:t>
+              <a:t>Satellite gravity — dense coverage, but ambiguous</a:t>
             </a:r>
             <a:endParaRPr lang="en-US" sz="3000" dirty="0"/>
           </a:p>
@@ -2714,12 +2864,12 @@
         </p:nvSpPr>
         <p:spPr>
           <a:xfrm>
-            <a:off x="768096" y="1819656"/>
-            <a:ext cx="4864608" cy="4224528"/>
+            <a:off x="768096" y="1773936"/>
+            <a:ext cx="5321808" cy="4315968"/>
           </a:xfrm>
           <a:prstGeom prst="roundRect">
             <a:avLst>
-              <a:gd name="adj" fmla="val 1299"/>
+              <a:gd name="adj" fmla="val 1271"/>
             </a:avLst>
           </a:prstGeom>
           <a:solidFill>
@@ -2742,7 +2892,7 @@
       </p:sp>
       <p:pic>
         <p:nvPicPr>
-          <p:cNvPr id="6" name="Image 0" descr="/Users/maswiet/Work/Students/Pak_Zuhdi/figures/rf_java/rf_vs_gravity.png">    </p:cNvPr>
+          <p:cNvPr id="6" name="Image 0" descr="/Users/maswiet/Work/Students/Pak_Zuhdi/figures/rf_java/bouguer.png">    </p:cNvPr>
           <p:cNvPicPr>
             <a:picLocks noChangeAspect="1"/>
           </p:cNvPicPr>
@@ -2755,8 +2905,8 @@
         </p:blipFill>
         <p:spPr>
           <a:xfrm>
-            <a:off x="822960" y="1874520"/>
-            <a:ext cx="4754880" cy="4114800"/>
+            <a:off x="822960" y="1828800"/>
+            <a:ext cx="5212080" cy="4206240"/>
           </a:xfrm>
           <a:prstGeom prst="rect">
             <a:avLst/>
@@ -2771,174 +2921,130 @@
         </p:nvSpPr>
         <p:spPr>
           <a:xfrm>
-            <a:off x="6035040" y="1874520"/>
-            <a:ext cx="5303520" cy="4114800"/>
+            <a:off x="6117336" y="1773936"/>
+            <a:ext cx="5321808" cy="4315968"/>
           </a:xfrm>
           <a:prstGeom prst="roundRect">
             <a:avLst>
-              <a:gd name="adj" fmla="val 2222"/>
+              <a:gd name="adj" fmla="val 1271"/>
             </a:avLst>
           </a:prstGeom>
           <a:solidFill>
-            <a:srgbClr val="10233A"/>
+            <a:srgbClr val="EEF3F6"/>
           </a:solidFill>
-          <a:ln/>
-        </p:spPr>
-      </p:sp>
-      <p:sp>
-        <p:nvSpPr>
-          <p:cNvPr id="8" name="Text 5"/>
-          <p:cNvSpPr txBox="1"/>
-          <p:nvPr/>
-        </p:nvSpPr>
-        <p:spPr>
-          <a:xfrm>
-            <a:off x="6355080" y="2148840"/>
-            <a:ext cx="4663440" cy="548640"/>
-          </a:xfrm>
-          <a:prstGeom prst="rect">
-            <a:avLst/>
-          </a:prstGeom>
-          <a:noFill/>
-          <a:ln/>
-        </p:spPr>
-        <p:txBody>
-          <a:bodyPr wrap="square" lIns="0" tIns="0" rIns="0" bIns="0" rtlCol="0" anchor="ctr"/>
-          <a:lstStyle/>
-          <a:p>
-            <a:pPr indent="0" marL="0">
-              <a:buNone/>
-            </a:pPr>
-            <a:r>
-              <a:rPr lang="en-US" sz="2400" b="1" dirty="0">
-                <a:solidFill>
-                  <a:srgbClr val="02C39A"/>
-                </a:solidFill>
-                <a:latin typeface="Cambria" pitchFamily="34" charset="0"/>
-                <a:ea typeface="Cambria" pitchFamily="34" charset="-122"/>
-                <a:cs typeface="Cambria" pitchFamily="34" charset="-120"/>
-              </a:rPr>
-              <a:t>Correlation r ≈ 0.1</a:t>
-            </a:r>
-            <a:endParaRPr lang="en-US" sz="2400" dirty="0"/>
-          </a:p>
-        </p:txBody>
-      </p:sp>
-      <p:sp>
-        <p:nvSpPr>
-          <p:cNvPr id="9" name="Text 6"/>
-          <p:cNvSpPr txBox="1"/>
-          <p:nvPr/>
-        </p:nvSpPr>
-        <p:spPr>
-          <a:xfrm>
-            <a:off x="6355080" y="2788920"/>
-            <a:ext cx="4663440" cy="3108960"/>
-          </a:xfrm>
-          <a:prstGeom prst="rect">
-            <a:avLst/>
-          </a:prstGeom>
-          <a:noFill/>
-          <a:ln/>
-        </p:spPr>
-        <p:txBody>
-          <a:bodyPr wrap="square" lIns="0" tIns="0" rIns="0" bIns="0" rtlCol="0" anchor="ctr"/>
-          <a:lstStyle/>
-          <a:p>
-            <a:pPr marL="342900" indent="-342900">
-              <a:lnSpc>
-                <a:spcPct val="110000"/>
-              </a:lnSpc>
-              <a:spcAft>
-                <a:spcPts val="1000"/>
-              </a:spcAft>
-              <a:buSzPct val="100000"/>
-              <a:buChar char="•"/>
-            </a:pPr>
-            <a:r>
-              <a:rPr lang="en-US" sz="1450" dirty="0">
-                <a:solidFill>
-                  <a:srgbClr val="E4EEF3"/>
-                </a:solidFill>
-                <a:latin typeface="Calibri" pitchFamily="34" charset="0"/>
-                <a:ea typeface="Calibri" pitchFamily="34" charset="-122"/>
-                <a:cs typeface="Calibri" pitchFamily="34" charset="-120"/>
-              </a:rPr>
-              <a:t>RF sediment thickness does NOT track the Bouguer residual here.</a:t>
-            </a:r>
-            <a:endParaRPr lang="en-US" sz="1450" dirty="0"/>
-          </a:p>
-          <a:p>
-            <a:pPr marL="342900" indent="-342900">
-              <a:lnSpc>
-                <a:spcPct val="110000"/>
-              </a:lnSpc>
-              <a:spcAft>
-                <a:spcPts val="1000"/>
-              </a:spcAft>
-              <a:buSzPct val="100000"/>
-              <a:buChar char="•"/>
-            </a:pPr>
-            <a:r>
-              <a:rPr lang="en-US" sz="1450" dirty="0">
-                <a:solidFill>
-                  <a:srgbClr val="E4EEF3"/>
-                </a:solidFill>
-                <a:latin typeface="Calibri" pitchFamily="34" charset="0"/>
-                <a:ea typeface="Calibri" pitchFamily="34" charset="-122"/>
-                <a:cs typeface="Calibri" pitchFamily="34" charset="-120"/>
-              </a:rPr>
-              <a:t>Why: Central Java's gravity field is dominated by the volcanic arc and basement density — not by thin, low-density sediment.</a:t>
-            </a:r>
-            <a:endParaRPr lang="en-US" sz="1450" dirty="0"/>
-          </a:p>
-          <a:p>
-            <a:pPr marL="342900" indent="-342900">
-              <a:lnSpc>
-                <a:spcPct val="110000"/>
-              </a:lnSpc>
-              <a:spcAft>
-                <a:spcPts val="1000"/>
-              </a:spcAft>
-              <a:buSzPct val="100000"/>
-              <a:buChar char="•"/>
-            </a:pPr>
-            <a:r>
-              <a:rPr lang="en-US" sz="1450" dirty="0">
-                <a:solidFill>
-                  <a:srgbClr val="E4EEF3"/>
-                </a:solidFill>
-                <a:latin typeface="Calibri" pitchFamily="34" charset="0"/>
-                <a:ea typeface="Calibri" pitchFamily="34" charset="-122"/>
-                <a:cs typeface="Calibri" pitchFamily="34" charset="-120"/>
-              </a:rPr>
-              <a:t>So gravity inversion for sediment is under-determined without an independent depth control.</a:t>
-            </a:r>
-            <a:endParaRPr lang="en-US" sz="1450" dirty="0"/>
-          </a:p>
-          <a:p>
-            <a:pPr marL="342900" indent="-342900">
-              <a:lnSpc>
-                <a:spcPct val="110000"/>
-              </a:lnSpc>
-              <a:spcAft>
-                <a:spcPts val="1000"/>
-              </a:spcAft>
-              <a:buSzPct val="100000"/>
-              <a:buChar char="•"/>
-            </a:pPr>
-            <a:r>
-              <a:rPr lang="en-US" sz="1450" dirty="0">
-                <a:solidFill>
-                  <a:srgbClr val="02C39A"/>
-                </a:solidFill>
-                <a:latin typeface="Calibri" pitchFamily="34" charset="0"/>
-                <a:ea typeface="Calibri" pitchFamily="34" charset="-122"/>
-                <a:cs typeface="Calibri" pitchFamily="34" charset="-120"/>
-              </a:rPr>
-              <a:t>That control is the receiver function.</a:t>
-            </a:r>
-            <a:endParaRPr lang="en-US" sz="1450" dirty="0"/>
+          <a:ln w="12700">
+            <a:solidFill>
+              <a:srgbClr val="D3DEE5"/>
+            </a:solidFill>
+            <a:prstDash val="solid"/>
+          </a:ln>
+          <a:effectLst>
+            <a:outerShdw sx="100000" sy="100000" kx="0" ky="0" algn="bl" rotWithShape="0" blurRad="76200" dist="25400" dir="5400000">
+              <a:srgbClr val="9AA9B2">
+                <a:alpha val="35000"/>
+              </a:srgbClr>
+            </a:outerShdw>
+          </a:effectLst>
+        </p:spPr>
+      </p:sp>
+      <p:pic>
+        <p:nvPicPr>
+          <p:cNvPr id="8" name="Image 1" descr="/Users/maswiet/Work/Students/Pak_Zuhdi/figures/rf_java/residual.png">    </p:cNvPr>
+          <p:cNvPicPr>
+            <a:picLocks noChangeAspect="1"/>
+          </p:cNvPicPr>
+          <p:nvPr/>
+        </p:nvPicPr>
+        <p:blipFill>
+          <a:blip r:embed="rId2"/>
+          <a:srcRect l="0" r="0" t="0" b="0"/>
+          <a:stretch/>
+        </p:blipFill>
+        <p:spPr>
+          <a:xfrm>
+            <a:off x="6172200" y="1828800"/>
+            <a:ext cx="5212080" cy="4206240"/>
+          </a:xfrm>
+          <a:prstGeom prst="rect">
+            <a:avLst/>
+          </a:prstGeom>
+        </p:spPr>
+      </p:pic>
+      <p:sp>
+        <p:nvSpPr>
+          <p:cNvPr id="9" name="Text 5"/>
+          <p:cNvSpPr txBox="1"/>
+          <p:nvPr/>
+        </p:nvSpPr>
+        <p:spPr>
+          <a:xfrm>
+            <a:off x="822960" y="6035040"/>
+            <a:ext cx="5212080" cy="365760"/>
+          </a:xfrm>
+          <a:prstGeom prst="rect">
+            <a:avLst/>
+          </a:prstGeom>
+          <a:noFill/>
+          <a:ln/>
+        </p:spPr>
+        <p:txBody>
+          <a:bodyPr wrap="square" lIns="0" tIns="0" rIns="0" bIns="0" rtlCol="0" anchor="ctr"/>
+          <a:lstStyle/>
+          <a:p>
+            <a:pPr algn="ctr" indent="0" marL="0">
+              <a:buNone/>
+            </a:pPr>
+            <a:r>
+              <a:rPr lang="en-US" sz="1200" b="1" dirty="0">
+                <a:solidFill>
+                  <a:srgbClr val="10233A"/>
+                </a:solidFill>
+                <a:latin typeface="Calibri" pitchFamily="34" charset="0"/>
+                <a:ea typeface="Calibri" pitchFamily="34" charset="-122"/>
+                <a:cs typeface="Calibri" pitchFamily="34" charset="-120"/>
+              </a:rPr>
+              <a:t>GGM+WGM complete Bouguer anomaly</a:t>
+            </a:r>
+            <a:endParaRPr lang="en-US" sz="1200" dirty="0"/>
+          </a:p>
+        </p:txBody>
+      </p:sp>
+      <p:sp>
+        <p:nvSpPr>
+          <p:cNvPr id="10" name="Text 6"/>
+          <p:cNvSpPr txBox="1"/>
+          <p:nvPr/>
+        </p:nvSpPr>
+        <p:spPr>
+          <a:xfrm>
+            <a:off x="6172200" y="6035040"/>
+            <a:ext cx="5212080" cy="365760"/>
+          </a:xfrm>
+          <a:prstGeom prst="rect">
+            <a:avLst/>
+          </a:prstGeom>
+          <a:noFill/>
+          <a:ln/>
+        </p:spPr>
+        <p:txBody>
+          <a:bodyPr wrap="square" lIns="0" tIns="0" rIns="0" bIns="0" rtlCol="0" anchor="ctr"/>
+          <a:lstStyle/>
+          <a:p>
+            <a:pPr algn="ctr" indent="0" marL="0">
+              <a:buNone/>
+            </a:pPr>
+            <a:r>
+              <a:rPr lang="en-US" sz="1200" b="1" dirty="0">
+                <a:solidFill>
+                  <a:srgbClr val="10233A"/>
+                </a:solidFill>
+                <a:latin typeface="Calibri" pitchFamily="34" charset="0"/>
+                <a:ea typeface="Calibri" pitchFamily="34" charset="-122"/>
+                <a:cs typeface="Calibri" pitchFamily="34" charset="-120"/>
+              </a:rPr>
+              <a:t>Residual (short-wavelength) — basin-scale signal</a:t>
+            </a:r>
+            <a:endParaRPr lang="en-US" sz="1200" dirty="0"/>
           </a:p>
         </p:txBody>
       </p:sp>
@@ -3027,7 +3133,7 @@
                 <a:ea typeface="Calibri" pitchFamily="34" charset="-122"/>
                 <a:cs typeface="Calibri" pitchFamily="34" charset="-120"/>
               </a:rPr>
-              <a:t>THE BRIDGE</a:t>
+              <a:t>THE KEY INSIGHT</a:t>
             </a:r>
             <a:endParaRPr lang="en-US" sz="1300" dirty="0"/>
           </a:p>
@@ -3066,7 +3172,7 @@
                 <a:ea typeface="Cambria" pitchFamily="34" charset="-122"/>
                 <a:cs typeface="Cambria" pitchFamily="34" charset="-120"/>
               </a:rPr>
-              <a:t>RF-anchored, gravity-contextualised sediment model</a:t>
+              <a:t>In a volcanic arc, gravity alone cannot see the sediment</a:t>
             </a:r>
             <a:endParaRPr lang="en-US" sz="3000" dirty="0"/>
           </a:p>
@@ -3080,12 +3186,12 @@
         </p:nvSpPr>
         <p:spPr>
           <a:xfrm>
-            <a:off x="768096" y="1728216"/>
-            <a:ext cx="6693408" cy="4681728"/>
+            <a:off x="768096" y="1819656"/>
+            <a:ext cx="4864608" cy="4224528"/>
           </a:xfrm>
           <a:prstGeom prst="roundRect">
             <a:avLst>
-              <a:gd name="adj" fmla="val 1172"/>
+              <a:gd name="adj" fmla="val 1299"/>
             </a:avLst>
           </a:prstGeom>
           <a:solidFill>
@@ -3108,7 +3214,7 @@
       </p:sp>
       <p:pic>
         <p:nvPicPr>
-          <p:cNvPr id="6" name="Image 0" descr="/Users/maswiet/Work/Students/Pak_Zuhdi/figures/rf_java/sediment_constrained.png">    </p:cNvPr>
+          <p:cNvPr id="6" name="Image 0" descr="/Users/maswiet/Work/Students/Pak_Zuhdi/figures/rf_java/rf_vs_gravity.png">    </p:cNvPr>
           <p:cNvPicPr>
             <a:picLocks noChangeAspect="1"/>
           </p:cNvPicPr>
@@ -3121,8 +3227,8 @@
         </p:blipFill>
         <p:spPr>
           <a:xfrm>
-            <a:off x="822960" y="1783080"/>
-            <a:ext cx="6583680" cy="4572000"/>
+            <a:off x="822960" y="1874520"/>
+            <a:ext cx="4754880" cy="4114800"/>
           </a:xfrm>
           <a:prstGeom prst="rect">
             <a:avLst/>
@@ -3131,14 +3237,36 @@
       </p:pic>
       <p:sp>
         <p:nvSpPr>
-          <p:cNvPr id="7" name="Text 4"/>
-          <p:cNvSpPr txBox="1"/>
-          <p:nvPr/>
-        </p:nvSpPr>
-        <p:spPr>
-          <a:xfrm>
-            <a:off x="7680960" y="1920240"/>
-            <a:ext cx="3840480" cy="365760"/>
+          <p:cNvPr id="7" name="Shape 4"/>
+          <p:cNvSpPr/>
+          <p:nvPr/>
+        </p:nvSpPr>
+        <p:spPr>
+          <a:xfrm>
+            <a:off x="6035040" y="1874520"/>
+            <a:ext cx="5303520" cy="4114800"/>
+          </a:xfrm>
+          <a:prstGeom prst="roundRect">
+            <a:avLst>
+              <a:gd name="adj" fmla="val 2222"/>
+            </a:avLst>
+          </a:prstGeom>
+          <a:solidFill>
+            <a:srgbClr val="10233A"/>
+          </a:solidFill>
+          <a:ln/>
+        </p:spPr>
+      </p:sp>
+      <p:sp>
+        <p:nvSpPr>
+          <p:cNvPr id="8" name="Text 5"/>
+          <p:cNvSpPr txBox="1"/>
+          <p:nvPr/>
+        </p:nvSpPr>
+        <p:spPr>
+          <a:xfrm>
+            <a:off x="6355080" y="2148840"/>
+            <a:ext cx="4663440" cy="548640"/>
           </a:xfrm>
           <a:prstGeom prst="rect">
             <a:avLst/>
@@ -3154,30 +3282,30 @@
               <a:buNone/>
             </a:pPr>
             <a:r>
-              <a:rPr lang="en-US" sz="1700" b="1" dirty="0">
-                <a:solidFill>
-                  <a:srgbClr val="1C7293"/>
-                </a:solidFill>
-                <a:latin typeface="Calibri" pitchFamily="34" charset="0"/>
-                <a:ea typeface="Calibri" pitchFamily="34" charset="-122"/>
-                <a:cs typeface="Calibri" pitchFamily="34" charset="-120"/>
-              </a:rPr>
-              <a:t>Integration</a:t>
-            </a:r>
-            <a:endParaRPr lang="en-US" sz="1700" dirty="0"/>
-          </a:p>
-        </p:txBody>
-      </p:sp>
-      <p:sp>
-        <p:nvSpPr>
-          <p:cNvPr id="8" name="Text 5"/>
-          <p:cNvSpPr txBox="1"/>
-          <p:nvPr/>
-        </p:nvSpPr>
-        <p:spPr>
-          <a:xfrm>
-            <a:off x="7680960" y="2331720"/>
-            <a:ext cx="3840480" cy="3017520"/>
+              <a:rPr lang="en-US" sz="2400" b="1" dirty="0">
+                <a:solidFill>
+                  <a:srgbClr val="02C39A"/>
+                </a:solidFill>
+                <a:latin typeface="Cambria" pitchFamily="34" charset="0"/>
+                <a:ea typeface="Cambria" pitchFamily="34" charset="-122"/>
+                <a:cs typeface="Cambria" pitchFamily="34" charset="-120"/>
+              </a:rPr>
+              <a:t>Correlation r ≈ 0.1</a:t>
+            </a:r>
+            <a:endParaRPr lang="en-US" sz="2400" dirty="0"/>
+          </a:p>
+        </p:txBody>
+      </p:sp>
+      <p:sp>
+        <p:nvSpPr>
+          <p:cNvPr id="9" name="Text 6"/>
+          <p:cNvSpPr txBox="1"/>
+          <p:nvPr/>
+        </p:nvSpPr>
+        <p:spPr>
+          <a:xfrm>
+            <a:off x="6355080" y="2788920"/>
+            <a:ext cx="4663440" cy="3108960"/>
           </a:xfrm>
           <a:prstGeom prst="rect">
             <a:avLst/>
@@ -3202,13 +3330,13 @@
             <a:r>
               <a:rPr lang="en-US" sz="1450" dirty="0">
                 <a:solidFill>
-                  <a:srgbClr val="10233A"/>
-                </a:solidFill>
-                <a:latin typeface="Calibri" pitchFamily="34" charset="0"/>
-                <a:ea typeface="Calibri" pitchFamily="34" charset="-122"/>
-                <a:cs typeface="Calibri" pitchFamily="34" charset="-120"/>
-              </a:rPr>
-              <a:t>Receiver functions set the absolute thickness at 103 points.</a:t>
+                  <a:srgbClr val="E4EEF3"/>
+                </a:solidFill>
+                <a:latin typeface="Calibri" pitchFamily="34" charset="0"/>
+                <a:ea typeface="Calibri" pitchFamily="34" charset="-122"/>
+                <a:cs typeface="Calibri" pitchFamily="34" charset="-120"/>
+              </a:rPr>
+              <a:t>RF sediment thickness does NOT track the Bouguer residual here.</a:t>
             </a:r>
             <a:endParaRPr lang="en-US" sz="1450" dirty="0"/>
           </a:p>
@@ -3226,13 +3354,13 @@
             <a:r>
               <a:rPr lang="en-US" sz="1450" dirty="0">
                 <a:solidFill>
-                  <a:srgbClr val="10233A"/>
-                </a:solidFill>
-                <a:latin typeface="Calibri" pitchFamily="34" charset="0"/>
-                <a:ea typeface="Calibri" pitchFamily="34" charset="-122"/>
-                <a:cs typeface="Calibri" pitchFamily="34" charset="-120"/>
-              </a:rPr>
-              <a:t>Gravity supplies the continuous spatial fabric between stations.</a:t>
+                  <a:srgbClr val="E4EEF3"/>
+                </a:solidFill>
+                <a:latin typeface="Calibri" pitchFamily="34" charset="0"/>
+                <a:ea typeface="Calibri" pitchFamily="34" charset="-122"/>
+                <a:cs typeface="Calibri" pitchFamily="34" charset="-120"/>
+              </a:rPr>
+              <a:t>Why: Central Java's gravity field is dominated by the volcanic arc and basement density — not by thin, low-density sediment.</a:t>
             </a:r>
             <a:endParaRPr lang="en-US" sz="1450" dirty="0"/>
           </a:p>
@@ -3250,13 +3378,13 @@
             <a:r>
               <a:rPr lang="en-US" sz="1450" dirty="0">
                 <a:solidFill>
-                  <a:srgbClr val="10233A"/>
-                </a:solidFill>
-                <a:latin typeface="Calibri" pitchFamily="34" charset="0"/>
-                <a:ea typeface="Calibri" pitchFamily="34" charset="-122"/>
-                <a:cs typeface="Calibri" pitchFamily="34" charset="-120"/>
-              </a:rPr>
-              <a:t>Collocation ties the map to the seismology (honours every station).</a:t>
+                  <a:srgbClr val="E4EEF3"/>
+                </a:solidFill>
+                <a:latin typeface="Calibri" pitchFamily="34" charset="0"/>
+                <a:ea typeface="Calibri" pitchFamily="34" charset="-122"/>
+                <a:cs typeface="Calibri" pitchFamily="34" charset="-120"/>
+              </a:rPr>
+              <a:t>So gravity inversion for sediment is under-determined without an independent depth control.</a:t>
             </a:r>
             <a:endParaRPr lang="en-US" sz="1450" dirty="0"/>
           </a:p>
@@ -3274,54 +3402,15 @@
             <a:r>
               <a:rPr lang="en-US" sz="1450" dirty="0">
                 <a:solidFill>
-                  <a:srgbClr val="10233A"/>
-                </a:solidFill>
-                <a:latin typeface="Calibri" pitchFamily="34" charset="0"/>
-                <a:ea typeface="Calibri" pitchFamily="34" charset="-122"/>
-                <a:cs typeface="Calibri" pitchFamily="34" charset="-120"/>
-              </a:rPr>
-              <a:t>A first, reconnaissance depth-to-basement model — from public data only.</a:t>
+                  <a:srgbClr val="02C39A"/>
+                </a:solidFill>
+                <a:latin typeface="Calibri" pitchFamily="34" charset="0"/>
+                <a:ea typeface="Calibri" pitchFamily="34" charset="-122"/>
+                <a:cs typeface="Calibri" pitchFamily="34" charset="-120"/>
+              </a:rPr>
+              <a:t>That control is the receiver function.</a:t>
             </a:r>
             <a:endParaRPr lang="en-US" sz="1450" dirty="0"/>
-          </a:p>
-        </p:txBody>
-      </p:sp>
-      <p:sp>
-        <p:nvSpPr>
-          <p:cNvPr id="9" name="Text 6"/>
-          <p:cNvSpPr txBox="1"/>
-          <p:nvPr/>
-        </p:nvSpPr>
-        <p:spPr>
-          <a:xfrm>
-            <a:off x="7680960" y="5486400"/>
-            <a:ext cx="3840480" cy="822960"/>
-          </a:xfrm>
-          <a:prstGeom prst="rect">
-            <a:avLst/>
-          </a:prstGeom>
-          <a:noFill/>
-          <a:ln/>
-        </p:spPr>
-        <p:txBody>
-          <a:bodyPr wrap="square" lIns="0" tIns="0" rIns="0" bIns="0" rtlCol="0" anchor="ctr"/>
-          <a:lstStyle/>
-          <a:p>
-            <a:pPr indent="0" marL="0">
-              <a:buNone/>
-            </a:pPr>
-            <a:r>
-              <a:rPr lang="en-US" sz="1500" b="1" i="1" dirty="0">
-                <a:solidFill>
-                  <a:srgbClr val="065A82"/>
-                </a:solidFill>
-                <a:latin typeface="Calibri" pitchFamily="34" charset="0"/>
-                <a:ea typeface="Calibri" pitchFamily="34" charset="-122"/>
-                <a:cs typeface="Calibri" pitchFamily="34" charset="-120"/>
-              </a:rPr>
-              <a:t>Seismology turns ambiguous gravity into a calibrated basin model.</a:t>
-            </a:r>
-            <a:endParaRPr lang="en-US" sz="1500" dirty="0"/>
           </a:p>
         </p:txBody>
       </p:sp>
@@ -3339,7 +3428,7 @@
     <p:bg>
       <p:bgPr>
         <a:solidFill>
-          <a:srgbClr val="10233A"/>
+          <a:srgbClr val="FFFFFF"/>
         </a:solidFill>
       </p:bgPr>
     </p:bg>
@@ -3365,8 +3454,8 @@
         </p:nvSpPr>
         <p:spPr>
           <a:xfrm>
-            <a:off x="822960" y="777240"/>
-            <a:ext cx="201168" cy="201168"/>
+            <a:off x="548640" y="566928"/>
+            <a:ext cx="164592" cy="164592"/>
           </a:xfrm>
           <a:prstGeom prst="ellipse">
             <a:avLst/>
@@ -3385,8 +3474,8 @@
         </p:nvSpPr>
         <p:spPr>
           <a:xfrm>
-            <a:off x="1143000" y="731520"/>
-            <a:ext cx="10058400" cy="365760"/>
+            <a:off x="822960" y="502920"/>
+            <a:ext cx="10789920" cy="310896"/>
           </a:xfrm>
           <a:prstGeom prst="rect">
             <a:avLst/>
@@ -3402,17 +3491,17 @@
               <a:buNone/>
             </a:pPr>
             <a:r>
-              <a:rPr lang="en-US" sz="1400" b="1" spc="200" kern="0" dirty="0">
-                <a:solidFill>
-                  <a:srgbClr val="02C39A"/>
-                </a:solidFill>
-                <a:latin typeface="Calibri" pitchFamily="34" charset="0"/>
-                <a:ea typeface="Calibri" pitchFamily="34" charset="-122"/>
-                <a:cs typeface="Calibri" pitchFamily="34" charset="-120"/>
-              </a:rPr>
-              <a:t>WHY IT MATTERS FOR EXPLORATION</a:t>
-            </a:r>
-            <a:endParaRPr lang="en-US" sz="1400" dirty="0"/>
+              <a:rPr lang="en-US" sz="1300" b="1" spc="200" kern="0" dirty="0">
+                <a:solidFill>
+                  <a:srgbClr val="1C7293"/>
+                </a:solidFill>
+                <a:latin typeface="Calibri" pitchFamily="34" charset="0"/>
+                <a:ea typeface="Calibri" pitchFamily="34" charset="-122"/>
+                <a:cs typeface="Calibri" pitchFamily="34" charset="-120"/>
+              </a:rPr>
+              <a:t>THE BRIDGE</a:t>
+            </a:r>
+            <a:endParaRPr lang="en-US" sz="1300" dirty="0"/>
           </a:p>
         </p:txBody>
       </p:sp>
@@ -3424,8 +3513,8 @@
         </p:nvSpPr>
         <p:spPr>
           <a:xfrm>
-            <a:off x="822960" y="1143000"/>
-            <a:ext cx="10515600" cy="822960"/>
+            <a:off x="804672" y="786384"/>
+            <a:ext cx="10881360" cy="822960"/>
           </a:xfrm>
           <a:prstGeom prst="rect">
             <a:avLst/>
@@ -3443,13 +3532,13 @@
             <a:r>
               <a:rPr lang="en-US" sz="3000" b="1" dirty="0">
                 <a:solidFill>
-                  <a:srgbClr val="FFFFFF"/>
+                  <a:srgbClr val="10233A"/>
                 </a:solidFill>
                 <a:latin typeface="Cambria" pitchFamily="34" charset="0"/>
                 <a:ea typeface="Cambria" pitchFamily="34" charset="-122"/>
                 <a:cs typeface="Cambria" pitchFamily="34" charset="-120"/>
               </a:rPr>
-              <a:t>A cheap, public-data workflow for frontier basins</a:t>
+              <a:t>RF-anchored, gravity-contextualised sediment model</a:t>
             </a:r>
             <a:endParaRPr lang="en-US" sz="3000" dirty="0"/>
           </a:p>
@@ -3463,35 +3552,65 @@
         </p:nvSpPr>
         <p:spPr>
           <a:xfrm>
-            <a:off x="822960" y="2286000"/>
-            <a:ext cx="5029200" cy="1645920"/>
+            <a:off x="768096" y="1728216"/>
+            <a:ext cx="6693408" cy="4681728"/>
           </a:xfrm>
           <a:prstGeom prst="roundRect">
             <a:avLst>
-              <a:gd name="adj" fmla="val 4444"/>
+              <a:gd name="adj" fmla="val 1172"/>
             </a:avLst>
           </a:prstGeom>
           <a:solidFill>
-            <a:srgbClr val="16324D"/>
+            <a:srgbClr val="EEF3F6"/>
           </a:solidFill>
           <a:ln w="12700">
             <a:solidFill>
-              <a:srgbClr val="1C7293"/>
+              <a:srgbClr val="D3DEE5"/>
             </a:solidFill>
             <a:prstDash val="solid"/>
           </a:ln>
-        </p:spPr>
-      </p:sp>
-      <p:sp>
-        <p:nvSpPr>
-          <p:cNvPr id="6" name="Text 4"/>
-          <p:cNvSpPr txBox="1"/>
-          <p:nvPr/>
-        </p:nvSpPr>
-        <p:spPr>
-          <a:xfrm>
-            <a:off x="1143000" y="2514600"/>
-            <a:ext cx="4480560" cy="457200"/>
+          <a:effectLst>
+            <a:outerShdw sx="100000" sy="100000" kx="0" ky="0" algn="bl" rotWithShape="0" blurRad="76200" dist="25400" dir="5400000">
+              <a:srgbClr val="9AA9B2">
+                <a:alpha val="35000"/>
+              </a:srgbClr>
+            </a:outerShdw>
+          </a:effectLst>
+        </p:spPr>
+      </p:sp>
+      <p:pic>
+        <p:nvPicPr>
+          <p:cNvPr id="6" name="Image 0" descr="/Users/maswiet/Work/Students/Pak_Zuhdi/figures/rf_java/sediment_constrained.png">    </p:cNvPr>
+          <p:cNvPicPr>
+            <a:picLocks noChangeAspect="1"/>
+          </p:cNvPicPr>
+          <p:nvPr/>
+        </p:nvPicPr>
+        <p:blipFill>
+          <a:blip r:embed="rId1"/>
+          <a:srcRect l="0" r="0" t="0" b="0"/>
+          <a:stretch/>
+        </p:blipFill>
+        <p:spPr>
+          <a:xfrm>
+            <a:off x="822960" y="1783080"/>
+            <a:ext cx="6583680" cy="4572000"/>
+          </a:xfrm>
+          <a:prstGeom prst="rect">
+            <a:avLst/>
+          </a:prstGeom>
+        </p:spPr>
+      </p:pic>
+      <p:sp>
+        <p:nvSpPr>
+          <p:cNvPr id="7" name="Text 4"/>
+          <p:cNvSpPr txBox="1"/>
+          <p:nvPr/>
+        </p:nvSpPr>
+        <p:spPr>
+          <a:xfrm>
+            <a:off x="7680960" y="1920240"/>
+            <a:ext cx="3840480" cy="365760"/>
           </a:xfrm>
           <a:prstGeom prst="rect">
             <a:avLst/>
@@ -3507,383 +3626,174 @@
               <a:buNone/>
             </a:pPr>
             <a:r>
-              <a:rPr lang="en-US" sz="1800" b="1" dirty="0">
-                <a:solidFill>
-                  <a:srgbClr val="02C39A"/>
-                </a:solidFill>
-                <a:latin typeface="Calibri" pitchFamily="34" charset="0"/>
-                <a:ea typeface="Calibri" pitchFamily="34" charset="-122"/>
-                <a:cs typeface="Calibri" pitchFamily="34" charset="-120"/>
-              </a:rPr>
-              <a:t>Reconnaissance first</a:t>
-            </a:r>
-            <a:endParaRPr lang="en-US" sz="1800" dirty="0"/>
-          </a:p>
-        </p:txBody>
-      </p:sp>
-      <p:sp>
-        <p:nvSpPr>
-          <p:cNvPr id="7" name="Text 5"/>
-          <p:cNvSpPr txBox="1"/>
-          <p:nvPr/>
-        </p:nvSpPr>
-        <p:spPr>
-          <a:xfrm>
-            <a:off x="1143000" y="2999232"/>
-            <a:ext cx="4480560" cy="822960"/>
-          </a:xfrm>
-          <a:prstGeom prst="rect">
-            <a:avLst/>
-          </a:prstGeom>
-          <a:noFill/>
-          <a:ln/>
-        </p:spPr>
-        <p:txBody>
-          <a:bodyPr wrap="square" lIns="0" tIns="0" rIns="0" bIns="0" rtlCol="0" anchor="ctr"/>
-          <a:lstStyle/>
-          <a:p>
-            <a:pPr indent="0" marL="0">
+              <a:rPr lang="en-US" sz="1700" b="1" dirty="0">
+                <a:solidFill>
+                  <a:srgbClr val="1C7293"/>
+                </a:solidFill>
+                <a:latin typeface="Calibri" pitchFamily="34" charset="0"/>
+                <a:ea typeface="Calibri" pitchFamily="34" charset="-122"/>
+                <a:cs typeface="Calibri" pitchFamily="34" charset="-120"/>
+              </a:rPr>
+              <a:t>Integration</a:t>
+            </a:r>
+            <a:endParaRPr lang="en-US" sz="1700" dirty="0"/>
+          </a:p>
+        </p:txBody>
+      </p:sp>
+      <p:sp>
+        <p:nvSpPr>
+          <p:cNvPr id="8" name="Text 5"/>
+          <p:cNvSpPr txBox="1"/>
+          <p:nvPr/>
+        </p:nvSpPr>
+        <p:spPr>
+          <a:xfrm>
+            <a:off x="7680960" y="2331720"/>
+            <a:ext cx="3840480" cy="3017520"/>
+          </a:xfrm>
+          <a:prstGeom prst="rect">
+            <a:avLst/>
+          </a:prstGeom>
+          <a:noFill/>
+          <a:ln/>
+        </p:spPr>
+        <p:txBody>
+          <a:bodyPr wrap="square" lIns="0" tIns="0" rIns="0" bIns="0" rtlCol="0" anchor="ctr"/>
+          <a:lstStyle/>
+          <a:p>
+            <a:pPr marL="342900" indent="-342900">
               <a:lnSpc>
                 <a:spcPct val="110000"/>
               </a:lnSpc>
-              <a:buNone/>
-            </a:pPr>
-            <a:r>
-              <a:rPr lang="en-US" sz="1400" dirty="0">
-                <a:solidFill>
-                  <a:srgbClr val="D6E4EC"/>
-                </a:solidFill>
-                <a:latin typeface="Calibri" pitchFamily="34" charset="0"/>
-                <a:ea typeface="Calibri" pitchFamily="34" charset="-122"/>
-                <a:cs typeface="Calibri" pitchFamily="34" charset="-120"/>
-              </a:rPr>
-              <a:t>Screen an under-explored basin for depocentres before committing to seismic.</a:t>
-            </a:r>
-            <a:endParaRPr lang="en-US" sz="1400" dirty="0"/>
-          </a:p>
-        </p:txBody>
-      </p:sp>
-      <p:sp>
-        <p:nvSpPr>
-          <p:cNvPr id="8" name="Shape 6"/>
-          <p:cNvSpPr/>
-          <p:nvPr/>
-        </p:nvSpPr>
-        <p:spPr>
-          <a:xfrm>
-            <a:off x="6309360" y="2286000"/>
-            <a:ext cx="5029200" cy="1645920"/>
-          </a:xfrm>
-          <a:prstGeom prst="roundRect">
-            <a:avLst>
-              <a:gd name="adj" fmla="val 4444"/>
-            </a:avLst>
-          </a:prstGeom>
-          <a:solidFill>
-            <a:srgbClr val="16324D"/>
-          </a:solidFill>
-          <a:ln w="12700">
-            <a:solidFill>
-              <a:srgbClr val="1C7293"/>
-            </a:solidFill>
-            <a:prstDash val="solid"/>
-          </a:ln>
-        </p:spPr>
-      </p:sp>
-      <p:sp>
-        <p:nvSpPr>
-          <p:cNvPr id="9" name="Text 7"/>
-          <p:cNvSpPr txBox="1"/>
-          <p:nvPr/>
-        </p:nvSpPr>
-        <p:spPr>
-          <a:xfrm>
-            <a:off x="6629400" y="2514600"/>
-            <a:ext cx="4480560" cy="457200"/>
-          </a:xfrm>
-          <a:prstGeom prst="rect">
-            <a:avLst/>
-          </a:prstGeom>
-          <a:noFill/>
-          <a:ln/>
-        </p:spPr>
-        <p:txBody>
-          <a:bodyPr wrap="square" lIns="0" tIns="0" rIns="0" bIns="0" rtlCol="0" anchor="ctr"/>
-          <a:lstStyle/>
-          <a:p>
-            <a:pPr indent="0" marL="0">
-              <a:buNone/>
-            </a:pPr>
-            <a:r>
-              <a:rPr lang="en-US" sz="1800" b="1" dirty="0">
-                <a:solidFill>
-                  <a:srgbClr val="02C39A"/>
-                </a:solidFill>
-                <a:latin typeface="Calibri" pitchFamily="34" charset="0"/>
-                <a:ea typeface="Calibri" pitchFamily="34" charset="-122"/>
-                <a:cs typeface="Calibri" pitchFamily="34" charset="-120"/>
-              </a:rPr>
-              <a:t>Physical anchor</a:t>
-            </a:r>
-            <a:endParaRPr lang="en-US" sz="1800" dirty="0"/>
-          </a:p>
-        </p:txBody>
-      </p:sp>
-      <p:sp>
-        <p:nvSpPr>
-          <p:cNvPr id="10" name="Text 8"/>
-          <p:cNvSpPr txBox="1"/>
-          <p:nvPr/>
-        </p:nvSpPr>
-        <p:spPr>
-          <a:xfrm>
-            <a:off x="6629400" y="2999232"/>
-            <a:ext cx="4480560" cy="822960"/>
-          </a:xfrm>
-          <a:prstGeom prst="rect">
-            <a:avLst/>
-          </a:prstGeom>
-          <a:noFill/>
-          <a:ln/>
-        </p:spPr>
-        <p:txBody>
-          <a:bodyPr wrap="square" lIns="0" tIns="0" rIns="0" bIns="0" rtlCol="0" anchor="ctr"/>
-          <a:lstStyle/>
-          <a:p>
-            <a:pPr indent="0" marL="0">
+              <a:spcAft>
+                <a:spcPts val="1000"/>
+              </a:spcAft>
+              <a:buSzPct val="100000"/>
+              <a:buChar char="•"/>
+            </a:pPr>
+            <a:r>
+              <a:rPr lang="en-US" sz="1450" dirty="0">
+                <a:solidFill>
+                  <a:srgbClr val="10233A"/>
+                </a:solidFill>
+                <a:latin typeface="Calibri" pitchFamily="34" charset="0"/>
+                <a:ea typeface="Calibri" pitchFamily="34" charset="-122"/>
+                <a:cs typeface="Calibri" pitchFamily="34" charset="-120"/>
+              </a:rPr>
+              <a:t>Receiver functions set the absolute thickness at 103 points.</a:t>
+            </a:r>
+            <a:endParaRPr lang="en-US" sz="1450" dirty="0"/>
+          </a:p>
+          <a:p>
+            <a:pPr marL="342900" indent="-342900">
               <a:lnSpc>
                 <a:spcPct val="110000"/>
               </a:lnSpc>
-              <a:buNone/>
-            </a:pPr>
-            <a:r>
-              <a:rPr lang="en-US" sz="1400" dirty="0">
-                <a:solidFill>
-                  <a:srgbClr val="D6E4EC"/>
-                </a:solidFill>
-                <a:latin typeface="Calibri" pitchFamily="34" charset="0"/>
-                <a:ea typeface="Calibri" pitchFamily="34" charset="-122"/>
-                <a:cs typeface="Calibri" pitchFamily="34" charset="-120"/>
-              </a:rPr>
-              <a:t>RF gives absolute thickness where wells and reflection data are absent.</a:t>
-            </a:r>
-            <a:endParaRPr lang="en-US" sz="1400" dirty="0"/>
-          </a:p>
-        </p:txBody>
-      </p:sp>
-      <p:sp>
-        <p:nvSpPr>
-          <p:cNvPr id="11" name="Shape 9"/>
-          <p:cNvSpPr/>
-          <p:nvPr/>
-        </p:nvSpPr>
-        <p:spPr>
-          <a:xfrm>
-            <a:off x="822960" y="4160520"/>
-            <a:ext cx="5029200" cy="1645920"/>
-          </a:xfrm>
-          <a:prstGeom prst="roundRect">
-            <a:avLst>
-              <a:gd name="adj" fmla="val 4444"/>
-            </a:avLst>
-          </a:prstGeom>
-          <a:solidFill>
-            <a:srgbClr val="16324D"/>
-          </a:solidFill>
-          <a:ln w="12700">
-            <a:solidFill>
-              <a:srgbClr val="1C7293"/>
-            </a:solidFill>
-            <a:prstDash val="solid"/>
-          </a:ln>
-        </p:spPr>
-      </p:sp>
-      <p:sp>
-        <p:nvSpPr>
-          <p:cNvPr id="12" name="Text 10"/>
-          <p:cNvSpPr txBox="1"/>
-          <p:nvPr/>
-        </p:nvSpPr>
-        <p:spPr>
-          <a:xfrm>
-            <a:off x="1143000" y="4389120"/>
-            <a:ext cx="4480560" cy="457200"/>
-          </a:xfrm>
-          <a:prstGeom prst="rect">
-            <a:avLst/>
-          </a:prstGeom>
-          <a:noFill/>
-          <a:ln/>
-        </p:spPr>
-        <p:txBody>
-          <a:bodyPr wrap="square" lIns="0" tIns="0" rIns="0" bIns="0" rtlCol="0" anchor="ctr"/>
-          <a:lstStyle/>
-          <a:p>
-            <a:pPr indent="0" marL="0">
-              <a:buNone/>
-            </a:pPr>
-            <a:r>
-              <a:rPr lang="en-US" sz="1800" b="1" dirty="0">
-                <a:solidFill>
-                  <a:srgbClr val="02C39A"/>
-                </a:solidFill>
-                <a:latin typeface="Calibri" pitchFamily="34" charset="0"/>
-                <a:ea typeface="Calibri" pitchFamily="34" charset="-122"/>
-                <a:cs typeface="Calibri" pitchFamily="34" charset="-120"/>
-              </a:rPr>
-              <a:t>Re-use passive data</a:t>
-            </a:r>
-            <a:endParaRPr lang="en-US" sz="1800" dirty="0"/>
-          </a:p>
-        </p:txBody>
-      </p:sp>
-      <p:sp>
-        <p:nvSpPr>
-          <p:cNvPr id="13" name="Text 11"/>
-          <p:cNvSpPr txBox="1"/>
-          <p:nvPr/>
-        </p:nvSpPr>
-        <p:spPr>
-          <a:xfrm>
-            <a:off x="1143000" y="4873752"/>
-            <a:ext cx="4480560" cy="822960"/>
-          </a:xfrm>
-          <a:prstGeom prst="rect">
-            <a:avLst/>
-          </a:prstGeom>
-          <a:noFill/>
-          <a:ln/>
-        </p:spPr>
-        <p:txBody>
-          <a:bodyPr wrap="square" lIns="0" tIns="0" rIns="0" bIns="0" rtlCol="0" anchor="ctr"/>
-          <a:lstStyle/>
-          <a:p>
-            <a:pPr indent="0" marL="0">
+              <a:spcAft>
+                <a:spcPts val="1000"/>
+              </a:spcAft>
+              <a:buSzPct val="100000"/>
+              <a:buChar char="•"/>
+            </a:pPr>
+            <a:r>
+              <a:rPr lang="en-US" sz="1450" dirty="0">
+                <a:solidFill>
+                  <a:srgbClr val="10233A"/>
+                </a:solidFill>
+                <a:latin typeface="Calibri" pitchFamily="34" charset="0"/>
+                <a:ea typeface="Calibri" pitchFamily="34" charset="-122"/>
+                <a:cs typeface="Calibri" pitchFamily="34" charset="-120"/>
+              </a:rPr>
+              <a:t>Gravity supplies the continuous spatial fabric between stations.</a:t>
+            </a:r>
+            <a:endParaRPr lang="en-US" sz="1450" dirty="0"/>
+          </a:p>
+          <a:p>
+            <a:pPr marL="342900" indent="-342900">
               <a:lnSpc>
                 <a:spcPct val="110000"/>
               </a:lnSpc>
-              <a:buNone/>
-            </a:pPr>
-            <a:r>
-              <a:rPr lang="en-US" sz="1400" dirty="0">
-                <a:solidFill>
-                  <a:srgbClr val="D6E4EC"/>
-                </a:solidFill>
-                <a:latin typeface="Calibri" pitchFamily="34" charset="0"/>
-                <a:ea typeface="Calibri" pitchFamily="34" charset="-122"/>
-                <a:cs typeface="Calibri" pitchFamily="34" charset="-120"/>
-              </a:rPr>
-              <a:t>Any temporary or permanent broadband network already on the ground can be mined.</a:t>
-            </a:r>
-            <a:endParaRPr lang="en-US" sz="1400" dirty="0"/>
-          </a:p>
-        </p:txBody>
-      </p:sp>
-      <p:sp>
-        <p:nvSpPr>
-          <p:cNvPr id="14" name="Shape 12"/>
-          <p:cNvSpPr/>
-          <p:nvPr/>
-        </p:nvSpPr>
-        <p:spPr>
-          <a:xfrm>
-            <a:off x="6309360" y="4160520"/>
-            <a:ext cx="5029200" cy="1645920"/>
-          </a:xfrm>
-          <a:prstGeom prst="roundRect">
-            <a:avLst>
-              <a:gd name="adj" fmla="val 4444"/>
-            </a:avLst>
-          </a:prstGeom>
-          <a:solidFill>
-            <a:srgbClr val="16324D"/>
-          </a:solidFill>
-          <a:ln w="12700">
-            <a:solidFill>
-              <a:srgbClr val="1C7293"/>
-            </a:solidFill>
-            <a:prstDash val="solid"/>
-          </a:ln>
-        </p:spPr>
-      </p:sp>
-      <p:sp>
-        <p:nvSpPr>
-          <p:cNvPr id="15" name="Text 13"/>
-          <p:cNvSpPr txBox="1"/>
-          <p:nvPr/>
-        </p:nvSpPr>
-        <p:spPr>
-          <a:xfrm>
-            <a:off x="6629400" y="4389120"/>
-            <a:ext cx="4480560" cy="457200"/>
-          </a:xfrm>
-          <a:prstGeom prst="rect">
-            <a:avLst/>
-          </a:prstGeom>
-          <a:noFill/>
-          <a:ln/>
-        </p:spPr>
-        <p:txBody>
-          <a:bodyPr wrap="square" lIns="0" tIns="0" rIns="0" bIns="0" rtlCol="0" anchor="ctr"/>
-          <a:lstStyle/>
-          <a:p>
-            <a:pPr indent="0" marL="0">
-              <a:buNone/>
-            </a:pPr>
-            <a:r>
-              <a:rPr lang="en-US" sz="1800" b="1" dirty="0">
-                <a:solidFill>
-                  <a:srgbClr val="02C39A"/>
-                </a:solidFill>
-                <a:latin typeface="Calibri" pitchFamily="34" charset="0"/>
-                <a:ea typeface="Calibri" pitchFamily="34" charset="-122"/>
-                <a:cs typeface="Calibri" pitchFamily="34" charset="-120"/>
-              </a:rPr>
-              <a:t>Scales nationally</a:t>
-            </a:r>
-            <a:endParaRPr lang="en-US" sz="1800" dirty="0"/>
-          </a:p>
-        </p:txBody>
-      </p:sp>
-      <p:sp>
-        <p:nvSpPr>
-          <p:cNvPr id="16" name="Text 14"/>
-          <p:cNvSpPr txBox="1"/>
-          <p:nvPr/>
-        </p:nvSpPr>
-        <p:spPr>
-          <a:xfrm>
-            <a:off x="6629400" y="4873752"/>
-            <a:ext cx="4480560" cy="822960"/>
-          </a:xfrm>
-          <a:prstGeom prst="rect">
-            <a:avLst/>
-          </a:prstGeom>
-          <a:noFill/>
-          <a:ln/>
-        </p:spPr>
-        <p:txBody>
-          <a:bodyPr wrap="square" lIns="0" tIns="0" rIns="0" bIns="0" rtlCol="0" anchor="ctr"/>
-          <a:lstStyle/>
-          <a:p>
-            <a:pPr indent="0" marL="0">
+              <a:spcAft>
+                <a:spcPts val="1000"/>
+              </a:spcAft>
+              <a:buSzPct val="100000"/>
+              <a:buChar char="•"/>
+            </a:pPr>
+            <a:r>
+              <a:rPr lang="en-US" sz="1450" dirty="0">
+                <a:solidFill>
+                  <a:srgbClr val="10233A"/>
+                </a:solidFill>
+                <a:latin typeface="Calibri" pitchFamily="34" charset="0"/>
+                <a:ea typeface="Calibri" pitchFamily="34" charset="-122"/>
+                <a:cs typeface="Calibri" pitchFamily="34" charset="-120"/>
+              </a:rPr>
+              <a:t>Collocation ties the map to the seismology (honours every station).</a:t>
+            </a:r>
+            <a:endParaRPr lang="en-US" sz="1450" dirty="0"/>
+          </a:p>
+          <a:p>
+            <a:pPr marL="342900" indent="-342900">
               <a:lnSpc>
                 <a:spcPct val="110000"/>
               </a:lnSpc>
-              <a:buNone/>
-            </a:pPr>
-            <a:r>
-              <a:rPr lang="en-US" sz="1400" dirty="0">
-                <a:solidFill>
-                  <a:srgbClr val="D6E4EC"/>
-                </a:solidFill>
-                <a:latin typeface="Calibri" pitchFamily="34" charset="0"/>
-                <a:ea typeface="Calibri" pitchFamily="34" charset="-122"/>
-                <a:cs typeface="Calibri" pitchFamily="34" charset="-120"/>
-              </a:rPr>
-              <a:t>Same recipe applies to Sumatra fore-arc, Makassar, Banda and other frontiers.</a:t>
-            </a:r>
-            <a:endParaRPr lang="en-US" sz="1400" dirty="0"/>
+              <a:spcAft>
+                <a:spcPts val="1000"/>
+              </a:spcAft>
+              <a:buSzPct val="100000"/>
+              <a:buChar char="•"/>
+            </a:pPr>
+            <a:r>
+              <a:rPr lang="en-US" sz="1450" dirty="0">
+                <a:solidFill>
+                  <a:srgbClr val="10233A"/>
+                </a:solidFill>
+                <a:latin typeface="Calibri" pitchFamily="34" charset="0"/>
+                <a:ea typeface="Calibri" pitchFamily="34" charset="-122"/>
+                <a:cs typeface="Calibri" pitchFamily="34" charset="-120"/>
+              </a:rPr>
+              <a:t>A first, reconnaissance depth-to-basement model — from public data only.</a:t>
+            </a:r>
+            <a:endParaRPr lang="en-US" sz="1450" dirty="0"/>
+          </a:p>
+        </p:txBody>
+      </p:sp>
+      <p:sp>
+        <p:nvSpPr>
+          <p:cNvPr id="9" name="Text 6"/>
+          <p:cNvSpPr txBox="1"/>
+          <p:nvPr/>
+        </p:nvSpPr>
+        <p:spPr>
+          <a:xfrm>
+            <a:off x="7680960" y="5486400"/>
+            <a:ext cx="3840480" cy="822960"/>
+          </a:xfrm>
+          <a:prstGeom prst="rect">
+            <a:avLst/>
+          </a:prstGeom>
+          <a:noFill/>
+          <a:ln/>
+        </p:spPr>
+        <p:txBody>
+          <a:bodyPr wrap="square" lIns="0" tIns="0" rIns="0" bIns="0" rtlCol="0" anchor="ctr"/>
+          <a:lstStyle/>
+          <a:p>
+            <a:pPr indent="0" marL="0">
+              <a:buNone/>
+            </a:pPr>
+            <a:r>
+              <a:rPr lang="en-US" sz="1500" b="1" i="1" dirty="0">
+                <a:solidFill>
+                  <a:srgbClr val="065A82"/>
+                </a:solidFill>
+                <a:latin typeface="Calibri" pitchFamily="34" charset="0"/>
+                <a:ea typeface="Calibri" pitchFamily="34" charset="-122"/>
+                <a:cs typeface="Calibri" pitchFamily="34" charset="-120"/>
+              </a:rPr>
+              <a:t>Seismology turns ambiguous gravity into a calibrated basin model.</a:t>
+            </a:r>
+            <a:endParaRPr lang="en-US" sz="1500" dirty="0"/>
           </a:p>
         </p:txBody>
       </p:sp>
@@ -3927,6 +3837,568 @@
         </p:nvSpPr>
         <p:spPr>
           <a:xfrm>
+            <a:off x="822960" y="777240"/>
+            <a:ext cx="201168" cy="201168"/>
+          </a:xfrm>
+          <a:prstGeom prst="ellipse">
+            <a:avLst/>
+          </a:prstGeom>
+          <a:solidFill>
+            <a:srgbClr val="02C39A"/>
+          </a:solidFill>
+          <a:ln/>
+        </p:spPr>
+      </p:sp>
+      <p:sp>
+        <p:nvSpPr>
+          <p:cNvPr id="3" name="Text 1"/>
+          <p:cNvSpPr txBox="1"/>
+          <p:nvPr/>
+        </p:nvSpPr>
+        <p:spPr>
+          <a:xfrm>
+            <a:off x="1143000" y="731520"/>
+            <a:ext cx="10058400" cy="365760"/>
+          </a:xfrm>
+          <a:prstGeom prst="rect">
+            <a:avLst/>
+          </a:prstGeom>
+          <a:noFill/>
+          <a:ln/>
+        </p:spPr>
+        <p:txBody>
+          <a:bodyPr wrap="square" lIns="0" tIns="0" rIns="0" bIns="0" rtlCol="0" anchor="ctr"/>
+          <a:lstStyle/>
+          <a:p>
+            <a:pPr indent="0" marL="0">
+              <a:buNone/>
+            </a:pPr>
+            <a:r>
+              <a:rPr lang="en-US" sz="1400" b="1" spc="200" kern="0" dirty="0">
+                <a:solidFill>
+                  <a:srgbClr val="02C39A"/>
+                </a:solidFill>
+                <a:latin typeface="Calibri" pitchFamily="34" charset="0"/>
+                <a:ea typeface="Calibri" pitchFamily="34" charset="-122"/>
+                <a:cs typeface="Calibri" pitchFamily="34" charset="-120"/>
+              </a:rPr>
+              <a:t>WHY IT MATTERS FOR EXPLORATION</a:t>
+            </a:r>
+            <a:endParaRPr lang="en-US" sz="1400" dirty="0"/>
+          </a:p>
+        </p:txBody>
+      </p:sp>
+      <p:sp>
+        <p:nvSpPr>
+          <p:cNvPr id="4" name="Text 2"/>
+          <p:cNvSpPr txBox="1"/>
+          <p:nvPr/>
+        </p:nvSpPr>
+        <p:spPr>
+          <a:xfrm>
+            <a:off x="822960" y="1143000"/>
+            <a:ext cx="10515600" cy="822960"/>
+          </a:xfrm>
+          <a:prstGeom prst="rect">
+            <a:avLst/>
+          </a:prstGeom>
+          <a:noFill/>
+          <a:ln/>
+        </p:spPr>
+        <p:txBody>
+          <a:bodyPr wrap="square" lIns="0" tIns="0" rIns="0" bIns="0" rtlCol="0" anchor="ctr"/>
+          <a:lstStyle/>
+          <a:p>
+            <a:pPr indent="0" marL="0">
+              <a:buNone/>
+            </a:pPr>
+            <a:r>
+              <a:rPr lang="en-US" sz="3000" b="1" dirty="0">
+                <a:solidFill>
+                  <a:srgbClr val="FFFFFF"/>
+                </a:solidFill>
+                <a:latin typeface="Cambria" pitchFamily="34" charset="0"/>
+                <a:ea typeface="Cambria" pitchFamily="34" charset="-122"/>
+                <a:cs typeface="Cambria" pitchFamily="34" charset="-120"/>
+              </a:rPr>
+              <a:t>A cheap, public-data workflow for frontier basins</a:t>
+            </a:r>
+            <a:endParaRPr lang="en-US" sz="3000" dirty="0"/>
+          </a:p>
+        </p:txBody>
+      </p:sp>
+      <p:sp>
+        <p:nvSpPr>
+          <p:cNvPr id="5" name="Shape 3"/>
+          <p:cNvSpPr/>
+          <p:nvPr/>
+        </p:nvSpPr>
+        <p:spPr>
+          <a:xfrm>
+            <a:off x="822960" y="2286000"/>
+            <a:ext cx="5029200" cy="1645920"/>
+          </a:xfrm>
+          <a:prstGeom prst="roundRect">
+            <a:avLst>
+              <a:gd name="adj" fmla="val 4444"/>
+            </a:avLst>
+          </a:prstGeom>
+          <a:solidFill>
+            <a:srgbClr val="16324D"/>
+          </a:solidFill>
+          <a:ln w="12700">
+            <a:solidFill>
+              <a:srgbClr val="1C7293"/>
+            </a:solidFill>
+            <a:prstDash val="solid"/>
+          </a:ln>
+        </p:spPr>
+      </p:sp>
+      <p:sp>
+        <p:nvSpPr>
+          <p:cNvPr id="6" name="Text 4"/>
+          <p:cNvSpPr txBox="1"/>
+          <p:nvPr/>
+        </p:nvSpPr>
+        <p:spPr>
+          <a:xfrm>
+            <a:off x="1143000" y="2514600"/>
+            <a:ext cx="4480560" cy="457200"/>
+          </a:xfrm>
+          <a:prstGeom prst="rect">
+            <a:avLst/>
+          </a:prstGeom>
+          <a:noFill/>
+          <a:ln/>
+        </p:spPr>
+        <p:txBody>
+          <a:bodyPr wrap="square" lIns="0" tIns="0" rIns="0" bIns="0" rtlCol="0" anchor="ctr"/>
+          <a:lstStyle/>
+          <a:p>
+            <a:pPr indent="0" marL="0">
+              <a:buNone/>
+            </a:pPr>
+            <a:r>
+              <a:rPr lang="en-US" sz="1800" b="1" dirty="0">
+                <a:solidFill>
+                  <a:srgbClr val="02C39A"/>
+                </a:solidFill>
+                <a:latin typeface="Calibri" pitchFamily="34" charset="0"/>
+                <a:ea typeface="Calibri" pitchFamily="34" charset="-122"/>
+                <a:cs typeface="Calibri" pitchFamily="34" charset="-120"/>
+              </a:rPr>
+              <a:t>Reconnaissance first</a:t>
+            </a:r>
+            <a:endParaRPr lang="en-US" sz="1800" dirty="0"/>
+          </a:p>
+        </p:txBody>
+      </p:sp>
+      <p:sp>
+        <p:nvSpPr>
+          <p:cNvPr id="7" name="Text 5"/>
+          <p:cNvSpPr txBox="1"/>
+          <p:nvPr/>
+        </p:nvSpPr>
+        <p:spPr>
+          <a:xfrm>
+            <a:off x="1143000" y="2999232"/>
+            <a:ext cx="4480560" cy="822960"/>
+          </a:xfrm>
+          <a:prstGeom prst="rect">
+            <a:avLst/>
+          </a:prstGeom>
+          <a:noFill/>
+          <a:ln/>
+        </p:spPr>
+        <p:txBody>
+          <a:bodyPr wrap="square" lIns="0" tIns="0" rIns="0" bIns="0" rtlCol="0" anchor="ctr"/>
+          <a:lstStyle/>
+          <a:p>
+            <a:pPr indent="0" marL="0">
+              <a:lnSpc>
+                <a:spcPct val="110000"/>
+              </a:lnSpc>
+              <a:buNone/>
+            </a:pPr>
+            <a:r>
+              <a:rPr lang="en-US" sz="1400" dirty="0">
+                <a:solidFill>
+                  <a:srgbClr val="D6E4EC"/>
+                </a:solidFill>
+                <a:latin typeface="Calibri" pitchFamily="34" charset="0"/>
+                <a:ea typeface="Calibri" pitchFamily="34" charset="-122"/>
+                <a:cs typeface="Calibri" pitchFamily="34" charset="-120"/>
+              </a:rPr>
+              <a:t>Screen an under-explored basin for depocentres before committing to seismic.</a:t>
+            </a:r>
+            <a:endParaRPr lang="en-US" sz="1400" dirty="0"/>
+          </a:p>
+        </p:txBody>
+      </p:sp>
+      <p:sp>
+        <p:nvSpPr>
+          <p:cNvPr id="8" name="Shape 6"/>
+          <p:cNvSpPr/>
+          <p:nvPr/>
+        </p:nvSpPr>
+        <p:spPr>
+          <a:xfrm>
+            <a:off x="6309360" y="2286000"/>
+            <a:ext cx="5029200" cy="1645920"/>
+          </a:xfrm>
+          <a:prstGeom prst="roundRect">
+            <a:avLst>
+              <a:gd name="adj" fmla="val 4444"/>
+            </a:avLst>
+          </a:prstGeom>
+          <a:solidFill>
+            <a:srgbClr val="16324D"/>
+          </a:solidFill>
+          <a:ln w="12700">
+            <a:solidFill>
+              <a:srgbClr val="1C7293"/>
+            </a:solidFill>
+            <a:prstDash val="solid"/>
+          </a:ln>
+        </p:spPr>
+      </p:sp>
+      <p:sp>
+        <p:nvSpPr>
+          <p:cNvPr id="9" name="Text 7"/>
+          <p:cNvSpPr txBox="1"/>
+          <p:nvPr/>
+        </p:nvSpPr>
+        <p:spPr>
+          <a:xfrm>
+            <a:off x="6629400" y="2514600"/>
+            <a:ext cx="4480560" cy="457200"/>
+          </a:xfrm>
+          <a:prstGeom prst="rect">
+            <a:avLst/>
+          </a:prstGeom>
+          <a:noFill/>
+          <a:ln/>
+        </p:spPr>
+        <p:txBody>
+          <a:bodyPr wrap="square" lIns="0" tIns="0" rIns="0" bIns="0" rtlCol="0" anchor="ctr"/>
+          <a:lstStyle/>
+          <a:p>
+            <a:pPr indent="0" marL="0">
+              <a:buNone/>
+            </a:pPr>
+            <a:r>
+              <a:rPr lang="en-US" sz="1800" b="1" dirty="0">
+                <a:solidFill>
+                  <a:srgbClr val="02C39A"/>
+                </a:solidFill>
+                <a:latin typeface="Calibri" pitchFamily="34" charset="0"/>
+                <a:ea typeface="Calibri" pitchFamily="34" charset="-122"/>
+                <a:cs typeface="Calibri" pitchFamily="34" charset="-120"/>
+              </a:rPr>
+              <a:t>Physical anchor</a:t>
+            </a:r>
+            <a:endParaRPr lang="en-US" sz="1800" dirty="0"/>
+          </a:p>
+        </p:txBody>
+      </p:sp>
+      <p:sp>
+        <p:nvSpPr>
+          <p:cNvPr id="10" name="Text 8"/>
+          <p:cNvSpPr txBox="1"/>
+          <p:nvPr/>
+        </p:nvSpPr>
+        <p:spPr>
+          <a:xfrm>
+            <a:off x="6629400" y="2999232"/>
+            <a:ext cx="4480560" cy="822960"/>
+          </a:xfrm>
+          <a:prstGeom prst="rect">
+            <a:avLst/>
+          </a:prstGeom>
+          <a:noFill/>
+          <a:ln/>
+        </p:spPr>
+        <p:txBody>
+          <a:bodyPr wrap="square" lIns="0" tIns="0" rIns="0" bIns="0" rtlCol="0" anchor="ctr"/>
+          <a:lstStyle/>
+          <a:p>
+            <a:pPr indent="0" marL="0">
+              <a:lnSpc>
+                <a:spcPct val="110000"/>
+              </a:lnSpc>
+              <a:buNone/>
+            </a:pPr>
+            <a:r>
+              <a:rPr lang="en-US" sz="1400" dirty="0">
+                <a:solidFill>
+                  <a:srgbClr val="D6E4EC"/>
+                </a:solidFill>
+                <a:latin typeface="Calibri" pitchFamily="34" charset="0"/>
+                <a:ea typeface="Calibri" pitchFamily="34" charset="-122"/>
+                <a:cs typeface="Calibri" pitchFamily="34" charset="-120"/>
+              </a:rPr>
+              <a:t>RF gives absolute thickness where wells and reflection data are absent.</a:t>
+            </a:r>
+            <a:endParaRPr lang="en-US" sz="1400" dirty="0"/>
+          </a:p>
+        </p:txBody>
+      </p:sp>
+      <p:sp>
+        <p:nvSpPr>
+          <p:cNvPr id="11" name="Shape 9"/>
+          <p:cNvSpPr/>
+          <p:nvPr/>
+        </p:nvSpPr>
+        <p:spPr>
+          <a:xfrm>
+            <a:off x="822960" y="4160520"/>
+            <a:ext cx="5029200" cy="1645920"/>
+          </a:xfrm>
+          <a:prstGeom prst="roundRect">
+            <a:avLst>
+              <a:gd name="adj" fmla="val 4444"/>
+            </a:avLst>
+          </a:prstGeom>
+          <a:solidFill>
+            <a:srgbClr val="16324D"/>
+          </a:solidFill>
+          <a:ln w="12700">
+            <a:solidFill>
+              <a:srgbClr val="1C7293"/>
+            </a:solidFill>
+            <a:prstDash val="solid"/>
+          </a:ln>
+        </p:spPr>
+      </p:sp>
+      <p:sp>
+        <p:nvSpPr>
+          <p:cNvPr id="12" name="Text 10"/>
+          <p:cNvSpPr txBox="1"/>
+          <p:nvPr/>
+        </p:nvSpPr>
+        <p:spPr>
+          <a:xfrm>
+            <a:off x="1143000" y="4389120"/>
+            <a:ext cx="4480560" cy="457200"/>
+          </a:xfrm>
+          <a:prstGeom prst="rect">
+            <a:avLst/>
+          </a:prstGeom>
+          <a:noFill/>
+          <a:ln/>
+        </p:spPr>
+        <p:txBody>
+          <a:bodyPr wrap="square" lIns="0" tIns="0" rIns="0" bIns="0" rtlCol="0" anchor="ctr"/>
+          <a:lstStyle/>
+          <a:p>
+            <a:pPr indent="0" marL="0">
+              <a:buNone/>
+            </a:pPr>
+            <a:r>
+              <a:rPr lang="en-US" sz="1800" b="1" dirty="0">
+                <a:solidFill>
+                  <a:srgbClr val="02C39A"/>
+                </a:solidFill>
+                <a:latin typeface="Calibri" pitchFamily="34" charset="0"/>
+                <a:ea typeface="Calibri" pitchFamily="34" charset="-122"/>
+                <a:cs typeface="Calibri" pitchFamily="34" charset="-120"/>
+              </a:rPr>
+              <a:t>Re-use passive data</a:t>
+            </a:r>
+            <a:endParaRPr lang="en-US" sz="1800" dirty="0"/>
+          </a:p>
+        </p:txBody>
+      </p:sp>
+      <p:sp>
+        <p:nvSpPr>
+          <p:cNvPr id="13" name="Text 11"/>
+          <p:cNvSpPr txBox="1"/>
+          <p:nvPr/>
+        </p:nvSpPr>
+        <p:spPr>
+          <a:xfrm>
+            <a:off x="1143000" y="4873752"/>
+            <a:ext cx="4480560" cy="822960"/>
+          </a:xfrm>
+          <a:prstGeom prst="rect">
+            <a:avLst/>
+          </a:prstGeom>
+          <a:noFill/>
+          <a:ln/>
+        </p:spPr>
+        <p:txBody>
+          <a:bodyPr wrap="square" lIns="0" tIns="0" rIns="0" bIns="0" rtlCol="0" anchor="ctr"/>
+          <a:lstStyle/>
+          <a:p>
+            <a:pPr indent="0" marL="0">
+              <a:lnSpc>
+                <a:spcPct val="110000"/>
+              </a:lnSpc>
+              <a:buNone/>
+            </a:pPr>
+            <a:r>
+              <a:rPr lang="en-US" sz="1400" dirty="0">
+                <a:solidFill>
+                  <a:srgbClr val="D6E4EC"/>
+                </a:solidFill>
+                <a:latin typeface="Calibri" pitchFamily="34" charset="0"/>
+                <a:ea typeface="Calibri" pitchFamily="34" charset="-122"/>
+                <a:cs typeface="Calibri" pitchFamily="34" charset="-120"/>
+              </a:rPr>
+              <a:t>Any temporary or permanent broadband network already on the ground can be mined.</a:t>
+            </a:r>
+            <a:endParaRPr lang="en-US" sz="1400" dirty="0"/>
+          </a:p>
+        </p:txBody>
+      </p:sp>
+      <p:sp>
+        <p:nvSpPr>
+          <p:cNvPr id="14" name="Shape 12"/>
+          <p:cNvSpPr/>
+          <p:nvPr/>
+        </p:nvSpPr>
+        <p:spPr>
+          <a:xfrm>
+            <a:off x="6309360" y="4160520"/>
+            <a:ext cx="5029200" cy="1645920"/>
+          </a:xfrm>
+          <a:prstGeom prst="roundRect">
+            <a:avLst>
+              <a:gd name="adj" fmla="val 4444"/>
+            </a:avLst>
+          </a:prstGeom>
+          <a:solidFill>
+            <a:srgbClr val="16324D"/>
+          </a:solidFill>
+          <a:ln w="12700">
+            <a:solidFill>
+              <a:srgbClr val="1C7293"/>
+            </a:solidFill>
+            <a:prstDash val="solid"/>
+          </a:ln>
+        </p:spPr>
+      </p:sp>
+      <p:sp>
+        <p:nvSpPr>
+          <p:cNvPr id="15" name="Text 13"/>
+          <p:cNvSpPr txBox="1"/>
+          <p:nvPr/>
+        </p:nvSpPr>
+        <p:spPr>
+          <a:xfrm>
+            <a:off x="6629400" y="4389120"/>
+            <a:ext cx="4480560" cy="457200"/>
+          </a:xfrm>
+          <a:prstGeom prst="rect">
+            <a:avLst/>
+          </a:prstGeom>
+          <a:noFill/>
+          <a:ln/>
+        </p:spPr>
+        <p:txBody>
+          <a:bodyPr wrap="square" lIns="0" tIns="0" rIns="0" bIns="0" rtlCol="0" anchor="ctr"/>
+          <a:lstStyle/>
+          <a:p>
+            <a:pPr indent="0" marL="0">
+              <a:buNone/>
+            </a:pPr>
+            <a:r>
+              <a:rPr lang="en-US" sz="1800" b="1" dirty="0">
+                <a:solidFill>
+                  <a:srgbClr val="02C39A"/>
+                </a:solidFill>
+                <a:latin typeface="Calibri" pitchFamily="34" charset="0"/>
+                <a:ea typeface="Calibri" pitchFamily="34" charset="-122"/>
+                <a:cs typeface="Calibri" pitchFamily="34" charset="-120"/>
+              </a:rPr>
+              <a:t>Scales nationally</a:t>
+            </a:r>
+            <a:endParaRPr lang="en-US" sz="1800" dirty="0"/>
+          </a:p>
+        </p:txBody>
+      </p:sp>
+      <p:sp>
+        <p:nvSpPr>
+          <p:cNvPr id="16" name="Text 14"/>
+          <p:cNvSpPr txBox="1"/>
+          <p:nvPr/>
+        </p:nvSpPr>
+        <p:spPr>
+          <a:xfrm>
+            <a:off x="6629400" y="4873752"/>
+            <a:ext cx="4480560" cy="822960"/>
+          </a:xfrm>
+          <a:prstGeom prst="rect">
+            <a:avLst/>
+          </a:prstGeom>
+          <a:noFill/>
+          <a:ln/>
+        </p:spPr>
+        <p:txBody>
+          <a:bodyPr wrap="square" lIns="0" tIns="0" rIns="0" bIns="0" rtlCol="0" anchor="ctr"/>
+          <a:lstStyle/>
+          <a:p>
+            <a:pPr indent="0" marL="0">
+              <a:lnSpc>
+                <a:spcPct val="110000"/>
+              </a:lnSpc>
+              <a:buNone/>
+            </a:pPr>
+            <a:r>
+              <a:rPr lang="en-US" sz="1400" dirty="0">
+                <a:solidFill>
+                  <a:srgbClr val="D6E4EC"/>
+                </a:solidFill>
+                <a:latin typeface="Calibri" pitchFamily="34" charset="0"/>
+                <a:ea typeface="Calibri" pitchFamily="34" charset="-122"/>
+                <a:cs typeface="Calibri" pitchFamily="34" charset="-120"/>
+              </a:rPr>
+              <a:t>Same recipe applies to Sumatra fore-arc, Makassar, Banda and other frontiers.</a:t>
+            </a:r>
+            <a:endParaRPr lang="en-US" sz="1400" dirty="0"/>
+          </a:p>
+        </p:txBody>
+      </p:sp>
+    </p:spTree>
+  </p:cSld>
+  <p:clrMapOvr>
+    <a:masterClrMapping/>
+  </p:clrMapOvr>
+</p:sld>
+</file>
+
+<file path=ppt/slides/slide15.xml><?xml version="1.0" encoding="utf-8"?>
+<p:sld xmlns:a="http://schemas.openxmlformats.org/drawingml/2006/main" xmlns:r="http://schemas.openxmlformats.org/officeDocument/2006/relationships" xmlns:p="http://schemas.openxmlformats.org/presentationml/2006/main">
+  <p:cSld name="Slide 15">
+    <p:bg>
+      <p:bgPr>
+        <a:solidFill>
+          <a:srgbClr val="10233A"/>
+        </a:solidFill>
+      </p:bgPr>
+    </p:bg>
+    <p:spTree>
+      <p:nvGrpSpPr>
+        <p:cNvPr id="1" name=""/>
+        <p:cNvGrpSpPr/>
+        <p:nvPr/>
+      </p:nvGrpSpPr>
+      <p:grpSpPr>
+        <a:xfrm>
+          <a:off x="0" y="0"/>
+          <a:ext cx="0" cy="0"/>
+          <a:chOff x="0" y="0"/>
+          <a:chExt cx="0" cy="0"/>
+        </a:xfrm>
+      </p:grpSpPr>
+      <p:sp>
+        <p:nvSpPr>
+          <p:cNvPr id="2" name="Shape 0"/>
+          <p:cNvSpPr/>
+          <p:nvPr/>
+        </p:nvSpPr>
+        <p:spPr>
+          <a:xfrm>
             <a:off x="822960" y="2011680"/>
             <a:ext cx="274320" cy="274320"/>
           </a:xfrm>
@@ -7780,7 +8252,7 @@
                 <a:ea typeface="Calibri" pitchFamily="34" charset="-122"/>
                 <a:cs typeface="Calibri" pitchFamily="34" charset="-120"/>
               </a:rPr>
-              <a:t>THE EXPERIMENT</a:t>
+              <a:t>DEEPER INVERSION</a:t>
             </a:r>
             <a:endParaRPr lang="en-US" sz="1300" dirty="0"/>
           </a:p>
@@ -7819,7 +8291,7 @@
                 <a:ea typeface="Cambria" pitchFamily="34" charset="-122"/>
                 <a:cs typeface="Cambria" pitchFamily="34" charset="-120"/>
               </a:rPr>
-              <a:t>MERAMEX 2004 — a dense passive array over Central Java</a:t>
+              <a:t>Full layered Vs profile from the receiver function</a:t>
             </a:r>
             <a:endParaRPr lang="en-US" sz="3000" dirty="0"/>
           </a:p>
@@ -7833,432 +8305,12 @@
         </p:nvSpPr>
         <p:spPr>
           <a:xfrm>
-            <a:off x="822960" y="1828800"/>
-            <a:ext cx="2606040" cy="1554480"/>
+            <a:off x="768096" y="1773936"/>
+            <a:ext cx="6876288" cy="4041648"/>
           </a:xfrm>
           <a:prstGeom prst="roundRect">
             <a:avLst>
-              <a:gd name="adj" fmla="val 4706"/>
-            </a:avLst>
-          </a:prstGeom>
-          <a:solidFill>
-            <a:srgbClr val="EEF3F6"/>
-          </a:solidFill>
-          <a:ln w="12700">
-            <a:solidFill>
-              <a:srgbClr val="DCE6EB"/>
-            </a:solidFill>
-            <a:prstDash val="solid"/>
-          </a:ln>
-        </p:spPr>
-      </p:sp>
-      <p:sp>
-        <p:nvSpPr>
-          <p:cNvPr id="6" name="Text 4"/>
-          <p:cNvSpPr txBox="1"/>
-          <p:nvPr/>
-        </p:nvSpPr>
-        <p:spPr>
-          <a:xfrm>
-            <a:off x="914400" y="2011680"/>
-            <a:ext cx="2423160" cy="731520"/>
-          </a:xfrm>
-          <a:prstGeom prst="rect">
-            <a:avLst/>
-          </a:prstGeom>
-          <a:noFill/>
-          <a:ln/>
-        </p:spPr>
-        <p:txBody>
-          <a:bodyPr wrap="square" lIns="0" tIns="0" rIns="0" bIns="0" rtlCol="0" anchor="ctr"/>
-          <a:lstStyle/>
-          <a:p>
-            <a:pPr algn="ctr" indent="0" marL="0">
-              <a:buNone/>
-            </a:pPr>
-            <a:r>
-              <a:rPr lang="en-US" sz="3400" b="1" dirty="0">
-                <a:solidFill>
-                  <a:srgbClr val="065A82"/>
-                </a:solidFill>
-                <a:latin typeface="Cambria" pitchFamily="34" charset="0"/>
-                <a:ea typeface="Cambria" pitchFamily="34" charset="-122"/>
-                <a:cs typeface="Cambria" pitchFamily="34" charset="-120"/>
-              </a:rPr>
-              <a:t>143</a:t>
-            </a:r>
-            <a:endParaRPr lang="en-US" sz="3400" dirty="0"/>
-          </a:p>
-        </p:txBody>
-      </p:sp>
-      <p:sp>
-        <p:nvSpPr>
-          <p:cNvPr id="7" name="Text 5"/>
-          <p:cNvSpPr txBox="1"/>
-          <p:nvPr/>
-        </p:nvSpPr>
-        <p:spPr>
-          <a:xfrm>
-            <a:off x="914400" y="2788920"/>
-            <a:ext cx="2423160" cy="457200"/>
-          </a:xfrm>
-          <a:prstGeom prst="rect">
-            <a:avLst/>
-          </a:prstGeom>
-          <a:noFill/>
-          <a:ln/>
-        </p:spPr>
-        <p:txBody>
-          <a:bodyPr wrap="square" lIns="0" tIns="0" rIns="0" bIns="0" rtlCol="0" anchor="ctr"/>
-          <a:lstStyle/>
-          <a:p>
-            <a:pPr algn="ctr" indent="0" marL="0">
-              <a:buNone/>
-            </a:pPr>
-            <a:r>
-              <a:rPr lang="en-US" sz="1300" dirty="0">
-                <a:solidFill>
-                  <a:srgbClr val="5A6B78"/>
-                </a:solidFill>
-                <a:latin typeface="Calibri" pitchFamily="34" charset="0"/>
-                <a:ea typeface="Calibri" pitchFamily="34" charset="-122"/>
-                <a:cs typeface="Calibri" pitchFamily="34" charset="-120"/>
-              </a:rPr>
-              <a:t>seismic stations</a:t>
-            </a:r>
-            <a:endParaRPr lang="en-US" sz="1300" dirty="0"/>
-          </a:p>
-        </p:txBody>
-      </p:sp>
-      <p:sp>
-        <p:nvSpPr>
-          <p:cNvPr id="8" name="Shape 6"/>
-          <p:cNvSpPr/>
-          <p:nvPr/>
-        </p:nvSpPr>
-        <p:spPr>
-          <a:xfrm>
-            <a:off x="3611880" y="1828800"/>
-            <a:ext cx="2606040" cy="1554480"/>
-          </a:xfrm>
-          <a:prstGeom prst="roundRect">
-            <a:avLst>
-              <a:gd name="adj" fmla="val 4706"/>
-            </a:avLst>
-          </a:prstGeom>
-          <a:solidFill>
-            <a:srgbClr val="EEF3F6"/>
-          </a:solidFill>
-          <a:ln w="12700">
-            <a:solidFill>
-              <a:srgbClr val="DCE6EB"/>
-            </a:solidFill>
-            <a:prstDash val="solid"/>
-          </a:ln>
-        </p:spPr>
-      </p:sp>
-      <p:sp>
-        <p:nvSpPr>
-          <p:cNvPr id="9" name="Text 7"/>
-          <p:cNvSpPr txBox="1"/>
-          <p:nvPr/>
-        </p:nvSpPr>
-        <p:spPr>
-          <a:xfrm>
-            <a:off x="3703320" y="2011680"/>
-            <a:ext cx="2423160" cy="731520"/>
-          </a:xfrm>
-          <a:prstGeom prst="rect">
-            <a:avLst/>
-          </a:prstGeom>
-          <a:noFill/>
-          <a:ln/>
-        </p:spPr>
-        <p:txBody>
-          <a:bodyPr wrap="square" lIns="0" tIns="0" rIns="0" bIns="0" rtlCol="0" anchor="ctr"/>
-          <a:lstStyle/>
-          <a:p>
-            <a:pPr algn="ctr" indent="0" marL="0">
-              <a:buNone/>
-            </a:pPr>
-            <a:r>
-              <a:rPr lang="en-US" sz="3400" b="1" dirty="0">
-                <a:solidFill>
-                  <a:srgbClr val="065A82"/>
-                </a:solidFill>
-                <a:latin typeface="Cambria" pitchFamily="34" charset="0"/>
-                <a:ea typeface="Cambria" pitchFamily="34" charset="-122"/>
-                <a:cs typeface="Cambria" pitchFamily="34" charset="-120"/>
-              </a:rPr>
-              <a:t>110</a:t>
-            </a:r>
-            <a:endParaRPr lang="en-US" sz="3400" dirty="0"/>
-          </a:p>
-        </p:txBody>
-      </p:sp>
-      <p:sp>
-        <p:nvSpPr>
-          <p:cNvPr id="10" name="Text 8"/>
-          <p:cNvSpPr txBox="1"/>
-          <p:nvPr/>
-        </p:nvSpPr>
-        <p:spPr>
-          <a:xfrm>
-            <a:off x="3703320" y="2788920"/>
-            <a:ext cx="2423160" cy="457200"/>
-          </a:xfrm>
-          <a:prstGeom prst="rect">
-            <a:avLst/>
-          </a:prstGeom>
-          <a:noFill/>
-          <a:ln/>
-        </p:spPr>
-        <p:txBody>
-          <a:bodyPr wrap="square" lIns="0" tIns="0" rIns="0" bIns="0" rtlCol="0" anchor="ctr"/>
-          <a:lstStyle/>
-          <a:p>
-            <a:pPr algn="ctr" indent="0" marL="0">
-              <a:buNone/>
-            </a:pPr>
-            <a:r>
-              <a:rPr lang="en-US" sz="1300" dirty="0">
-                <a:solidFill>
-                  <a:srgbClr val="5A6B78"/>
-                </a:solidFill>
-                <a:latin typeface="Calibri" pitchFamily="34" charset="0"/>
-                <a:ea typeface="Calibri" pitchFamily="34" charset="-122"/>
-                <a:cs typeface="Calibri" pitchFamily="34" charset="-120"/>
-              </a:rPr>
-              <a:t>stations with RFs</a:t>
-            </a:r>
-            <a:endParaRPr lang="en-US" sz="1300" dirty="0"/>
-          </a:p>
-        </p:txBody>
-      </p:sp>
-      <p:sp>
-        <p:nvSpPr>
-          <p:cNvPr id="11" name="Shape 9"/>
-          <p:cNvSpPr/>
-          <p:nvPr/>
-        </p:nvSpPr>
-        <p:spPr>
-          <a:xfrm>
-            <a:off x="6400800" y="1828800"/>
-            <a:ext cx="2606040" cy="1554480"/>
-          </a:xfrm>
-          <a:prstGeom prst="roundRect">
-            <a:avLst>
-              <a:gd name="adj" fmla="val 4706"/>
-            </a:avLst>
-          </a:prstGeom>
-          <a:solidFill>
-            <a:srgbClr val="EEF3F6"/>
-          </a:solidFill>
-          <a:ln w="12700">
-            <a:solidFill>
-              <a:srgbClr val="DCE6EB"/>
-            </a:solidFill>
-            <a:prstDash val="solid"/>
-          </a:ln>
-        </p:spPr>
-      </p:sp>
-      <p:sp>
-        <p:nvSpPr>
-          <p:cNvPr id="12" name="Text 10"/>
-          <p:cNvSpPr txBox="1"/>
-          <p:nvPr/>
-        </p:nvSpPr>
-        <p:spPr>
-          <a:xfrm>
-            <a:off x="6492240" y="2011680"/>
-            <a:ext cx="2423160" cy="731520"/>
-          </a:xfrm>
-          <a:prstGeom prst="rect">
-            <a:avLst/>
-          </a:prstGeom>
-          <a:noFill/>
-          <a:ln/>
-        </p:spPr>
-        <p:txBody>
-          <a:bodyPr wrap="square" lIns="0" tIns="0" rIns="0" bIns="0" rtlCol="0" anchor="ctr"/>
-          <a:lstStyle/>
-          <a:p>
-            <a:pPr algn="ctr" indent="0" marL="0">
-              <a:buNone/>
-            </a:pPr>
-            <a:r>
-              <a:rPr lang="en-US" sz="3400" b="1" dirty="0">
-                <a:solidFill>
-                  <a:srgbClr val="065A82"/>
-                </a:solidFill>
-                <a:latin typeface="Cambria" pitchFamily="34" charset="0"/>
-                <a:ea typeface="Cambria" pitchFamily="34" charset="-122"/>
-                <a:cs typeface="Cambria" pitchFamily="34" charset="-120"/>
-              </a:rPr>
-              <a:t>7</a:t>
-            </a:r>
-            <a:endParaRPr lang="en-US" sz="3400" dirty="0"/>
-          </a:p>
-        </p:txBody>
-      </p:sp>
-      <p:sp>
-        <p:nvSpPr>
-          <p:cNvPr id="13" name="Text 11"/>
-          <p:cNvSpPr txBox="1"/>
-          <p:nvPr/>
-        </p:nvSpPr>
-        <p:spPr>
-          <a:xfrm>
-            <a:off x="6492240" y="2788920"/>
-            <a:ext cx="2423160" cy="457200"/>
-          </a:xfrm>
-          <a:prstGeom prst="rect">
-            <a:avLst/>
-          </a:prstGeom>
-          <a:noFill/>
-          <a:ln/>
-        </p:spPr>
-        <p:txBody>
-          <a:bodyPr wrap="square" lIns="0" tIns="0" rIns="0" bIns="0" rtlCol="0" anchor="ctr"/>
-          <a:lstStyle/>
-          <a:p>
-            <a:pPr algn="ctr" indent="0" marL="0">
-              <a:buNone/>
-            </a:pPr>
-            <a:r>
-              <a:rPr lang="en-US" sz="1300" dirty="0">
-                <a:solidFill>
-                  <a:srgbClr val="5A6B78"/>
-                </a:solidFill>
-                <a:latin typeface="Calibri" pitchFamily="34" charset="0"/>
-                <a:ea typeface="Calibri" pitchFamily="34" charset="-122"/>
-                <a:cs typeface="Calibri" pitchFamily="34" charset="-120"/>
-              </a:rPr>
-              <a:t>teleseisms used</a:t>
-            </a:r>
-            <a:endParaRPr lang="en-US" sz="1300" dirty="0"/>
-          </a:p>
-        </p:txBody>
-      </p:sp>
-      <p:sp>
-        <p:nvSpPr>
-          <p:cNvPr id="14" name="Shape 12"/>
-          <p:cNvSpPr/>
-          <p:nvPr/>
-        </p:nvSpPr>
-        <p:spPr>
-          <a:xfrm>
-            <a:off x="9189720" y="1828800"/>
-            <a:ext cx="2606040" cy="1554480"/>
-          </a:xfrm>
-          <a:prstGeom prst="roundRect">
-            <a:avLst>
-              <a:gd name="adj" fmla="val 4706"/>
-            </a:avLst>
-          </a:prstGeom>
-          <a:solidFill>
-            <a:srgbClr val="EEF3F6"/>
-          </a:solidFill>
-          <a:ln w="12700">
-            <a:solidFill>
-              <a:srgbClr val="DCE6EB"/>
-            </a:solidFill>
-            <a:prstDash val="solid"/>
-          </a:ln>
-        </p:spPr>
-      </p:sp>
-      <p:sp>
-        <p:nvSpPr>
-          <p:cNvPr id="15" name="Text 13"/>
-          <p:cNvSpPr txBox="1"/>
-          <p:nvPr/>
-        </p:nvSpPr>
-        <p:spPr>
-          <a:xfrm>
-            <a:off x="9281160" y="2011680"/>
-            <a:ext cx="2423160" cy="731520"/>
-          </a:xfrm>
-          <a:prstGeom prst="rect">
-            <a:avLst/>
-          </a:prstGeom>
-          <a:noFill/>
-          <a:ln/>
-        </p:spPr>
-        <p:txBody>
-          <a:bodyPr wrap="square" lIns="0" tIns="0" rIns="0" bIns="0" rtlCol="0" anchor="ctr"/>
-          <a:lstStyle/>
-          <a:p>
-            <a:pPr algn="ctr" indent="0" marL="0">
-              <a:buNone/>
-            </a:pPr>
-            <a:r>
-              <a:rPr lang="en-US" sz="3400" b="1" dirty="0">
-                <a:solidFill>
-                  <a:srgbClr val="065A82"/>
-                </a:solidFill>
-                <a:latin typeface="Cambria" pitchFamily="34" charset="0"/>
-                <a:ea typeface="Cambria" pitchFamily="34" charset="-122"/>
-                <a:cs typeface="Cambria" pitchFamily="34" charset="-120"/>
-              </a:rPr>
-              <a:t>~2.8 km</a:t>
-            </a:r>
-            <a:endParaRPr lang="en-US" sz="3400" dirty="0"/>
-          </a:p>
-        </p:txBody>
-      </p:sp>
-      <p:sp>
-        <p:nvSpPr>
-          <p:cNvPr id="16" name="Text 14"/>
-          <p:cNvSpPr txBox="1"/>
-          <p:nvPr/>
-        </p:nvSpPr>
-        <p:spPr>
-          <a:xfrm>
-            <a:off x="9281160" y="2788920"/>
-            <a:ext cx="2423160" cy="457200"/>
-          </a:xfrm>
-          <a:prstGeom prst="rect">
-            <a:avLst/>
-          </a:prstGeom>
-          <a:noFill/>
-          <a:ln/>
-        </p:spPr>
-        <p:txBody>
-          <a:bodyPr wrap="square" lIns="0" tIns="0" rIns="0" bIns="0" rtlCol="0" anchor="ctr"/>
-          <a:lstStyle/>
-          <a:p>
-            <a:pPr algn="ctr" indent="0" marL="0">
-              <a:buNone/>
-            </a:pPr>
-            <a:r>
-              <a:rPr lang="en-US" sz="1300" dirty="0">
-                <a:solidFill>
-                  <a:srgbClr val="5A6B78"/>
-                </a:solidFill>
-                <a:latin typeface="Calibri" pitchFamily="34" charset="0"/>
-                <a:ea typeface="Calibri" pitchFamily="34" charset="-122"/>
-                <a:cs typeface="Calibri" pitchFamily="34" charset="-120"/>
-              </a:rPr>
-              <a:t>median sediment</a:t>
-            </a:r>
-            <a:endParaRPr lang="en-US" sz="1300" dirty="0"/>
-          </a:p>
-        </p:txBody>
-      </p:sp>
-      <p:sp>
-        <p:nvSpPr>
-          <p:cNvPr id="17" name="Shape 15"/>
-          <p:cNvSpPr/>
-          <p:nvPr/>
-        </p:nvSpPr>
-        <p:spPr>
-          <a:xfrm>
-            <a:off x="3054096" y="3557016"/>
-            <a:ext cx="6053328" cy="3035808"/>
-          </a:xfrm>
-          <a:prstGeom prst="roundRect">
-            <a:avLst>
-              <a:gd name="adj" fmla="val 1807"/>
+              <a:gd name="adj" fmla="val 1357"/>
             </a:avLst>
           </a:prstGeom>
           <a:solidFill>
@@ -8281,7 +8333,7 @@
       </p:sp>
       <p:pic>
         <p:nvPicPr>
-          <p:cNvPr id="18" name="Image 0" descr="/Users/maswiet/Work/Students/Pak_Zuhdi/figures/rf_java/sediment_rf_map.png">    </p:cNvPr>
+          <p:cNvPr id="6" name="Image 0" descr="/Users/maswiet/Work/Students/Pak_Zuhdi/figures/rf_java/vs_inversion_BI4.png">    </p:cNvPr>
           <p:cNvPicPr>
             <a:picLocks noChangeAspect="1"/>
           </p:cNvPicPr>
@@ -8294,8 +8346,8 @@
         </p:blipFill>
         <p:spPr>
           <a:xfrm>
-            <a:off x="3108960" y="3611880"/>
-            <a:ext cx="5943600" cy="2926080"/>
+            <a:off x="822960" y="1828800"/>
+            <a:ext cx="6766560" cy="3931920"/>
           </a:xfrm>
           <a:prstGeom prst="rect">
             <a:avLst/>
@@ -8304,119 +8356,136 @@
       </p:pic>
       <p:sp>
         <p:nvSpPr>
-          <p:cNvPr id="19" name="Text 16"/>
-          <p:cNvSpPr txBox="1"/>
-          <p:nvPr/>
-        </p:nvSpPr>
-        <p:spPr>
-          <a:xfrm>
-            <a:off x="822960" y="3703320"/>
-            <a:ext cx="2194560" cy="2743200"/>
-          </a:xfrm>
-          <a:prstGeom prst="rect">
-            <a:avLst/>
-          </a:prstGeom>
-          <a:noFill/>
-          <a:ln/>
-        </p:spPr>
-        <p:txBody>
-          <a:bodyPr wrap="square" lIns="0" tIns="0" rIns="0" bIns="0" rtlCol="0" anchor="ctr"/>
-          <a:lstStyle/>
-          <a:p>
-            <a:pPr marL="342900" indent="-342900">
-              <a:lnSpc>
-                <a:spcPct val="105000"/>
-              </a:lnSpc>
-              <a:spcAft>
-                <a:spcPts val="900"/>
-              </a:spcAft>
-              <a:buSzPct val="100000"/>
-              <a:buChar char="•"/>
-            </a:pPr>
-            <a:r>
-              <a:rPr lang="en-US" sz="1300" dirty="0">
-                <a:solidFill>
-                  <a:srgbClr val="10233A"/>
-                </a:solidFill>
-                <a:latin typeface="Calibri" pitchFamily="34" charset="0"/>
-                <a:ea typeface="Calibri" pitchFamily="34" charset="-122"/>
-                <a:cs typeface="Calibri" pitchFamily="34" charset="-120"/>
-              </a:rPr>
-              <a:t>Merapi Amphibious Experiment (GFZ), May–Oct 2004.</a:t>
-            </a:r>
-            <a:endParaRPr lang="en-US" sz="1300" dirty="0"/>
-          </a:p>
-          <a:p>
-            <a:pPr marL="342900" indent="-342900">
-              <a:lnSpc>
-                <a:spcPct val="105000"/>
-              </a:lnSpc>
-              <a:spcAft>
-                <a:spcPts val="900"/>
-              </a:spcAft>
-              <a:buSzPct val="100000"/>
-              <a:buChar char="•"/>
-            </a:pPr>
-            <a:r>
-              <a:rPr lang="en-US" sz="1300" dirty="0">
-                <a:solidFill>
-                  <a:srgbClr val="10233A"/>
-                </a:solidFill>
-                <a:latin typeface="Calibri" pitchFamily="34" charset="0"/>
-                <a:ea typeface="Calibri" pitchFamily="34" charset="-122"/>
-                <a:cs typeface="Calibri" pitchFamily="34" charset="-120"/>
-              </a:rPr>
-              <a:t>Broadband + short-period stations, ~10–20 km spacing.</a:t>
-            </a:r>
-            <a:endParaRPr lang="en-US" sz="1300" dirty="0"/>
-          </a:p>
-          <a:p>
-            <a:pPr marL="342900" indent="-342900">
-              <a:lnSpc>
-                <a:spcPct val="105000"/>
-              </a:lnSpc>
-              <a:spcAft>
-                <a:spcPts val="900"/>
-              </a:spcAft>
-              <a:buSzPct val="100000"/>
-              <a:buChar char="•"/>
-            </a:pPr>
-            <a:r>
-              <a:rPr lang="en-US" sz="1300" dirty="0">
-                <a:solidFill>
-                  <a:srgbClr val="10233A"/>
-                </a:solidFill>
-                <a:latin typeface="Calibri" pitchFamily="34" charset="0"/>
-                <a:ea typeface="Calibri" pitchFamily="34" charset="-122"/>
-                <a:cs typeface="Calibri" pitchFamily="34" charset="-120"/>
-              </a:rPr>
-              <a:t>Public / experiment data — no new acquisition.</a:t>
-            </a:r>
-            <a:endParaRPr lang="en-US" sz="1300" dirty="0"/>
-          </a:p>
-          <a:p>
-            <a:pPr marL="342900" indent="-342900">
-              <a:lnSpc>
-                <a:spcPct val="105000"/>
-              </a:lnSpc>
-              <a:spcAft>
-                <a:spcPts val="900"/>
-              </a:spcAft>
-              <a:buSzPct val="100000"/>
-              <a:buChar char="•"/>
-            </a:pPr>
-            <a:r>
-              <a:rPr lang="en-US" sz="1300" dirty="0">
-                <a:solidFill>
-                  <a:srgbClr val="10233A"/>
-                </a:solidFill>
-                <a:latin typeface="Calibri" pitchFamily="34" charset="0"/>
-                <a:ea typeface="Calibri" pitchFamily="34" charset="-122"/>
-                <a:cs typeface="Calibri" pitchFamily="34" charset="-120"/>
-              </a:rPr>
-              <a:t>Each dot = one RF-derived sediment estimate.</a:t>
-            </a:r>
-            <a:endParaRPr lang="en-US" sz="1300" dirty="0"/>
+          <p:cNvPr id="7" name="Text 4"/>
+          <p:cNvSpPr txBox="1"/>
+          <p:nvPr/>
+        </p:nvSpPr>
+        <p:spPr>
+          <a:xfrm>
+            <a:off x="822960" y="5806440"/>
+            <a:ext cx="6766560" cy="548640"/>
+          </a:xfrm>
+          <a:prstGeom prst="rect">
+            <a:avLst/>
+          </a:prstGeom>
+          <a:noFill/>
+          <a:ln/>
+        </p:spPr>
+        <p:txBody>
+          <a:bodyPr wrap="square" lIns="0" tIns="0" rIns="0" bIns="0" rtlCol="0" anchor="ctr"/>
+          <a:lstStyle/>
+          <a:p>
+            <a:pPr indent="0" marL="0">
+              <a:buNone/>
+            </a:pPr>
+            <a:r>
+              <a:rPr lang="en-US" sz="1000" i="1" dirty="0">
+                <a:solidFill>
+                  <a:srgbClr val="5A6B78"/>
+                </a:solidFill>
+                <a:latin typeface="Calibri" pitchFamily="34" charset="0"/>
+                <a:ea typeface="Calibri" pitchFamily="34" charset="-122"/>
+                <a:cs typeface="Calibri" pitchFamily="34" charset="-120"/>
+              </a:rPr>
+              <a:t>Station BI4 — linearised, damped, smoothed least-squares Vs inversion (CPS rftn96 scheme, hrftn96 forward). Observed vs predicted RF, RMS 0.08.</a:t>
+            </a:r>
+            <a:endParaRPr lang="en-US" sz="1000" dirty="0"/>
+          </a:p>
+        </p:txBody>
+      </p:sp>
+      <p:sp>
+        <p:nvSpPr>
+          <p:cNvPr id="8" name="Shape 5"/>
+          <p:cNvSpPr/>
+          <p:nvPr/>
+        </p:nvSpPr>
+        <p:spPr>
+          <a:xfrm>
+            <a:off x="7763256" y="1773936"/>
+            <a:ext cx="3767328" cy="4590288"/>
+          </a:xfrm>
+          <a:prstGeom prst="roundRect">
+            <a:avLst>
+              <a:gd name="adj" fmla="val 1456"/>
+            </a:avLst>
+          </a:prstGeom>
+          <a:solidFill>
+            <a:srgbClr val="EEF3F6"/>
+          </a:solidFill>
+          <a:ln w="12700">
+            <a:solidFill>
+              <a:srgbClr val="D3DEE5"/>
+            </a:solidFill>
+            <a:prstDash val="solid"/>
+          </a:ln>
+          <a:effectLst>
+            <a:outerShdw sx="100000" sy="100000" kx="0" ky="0" algn="bl" rotWithShape="0" blurRad="76200" dist="25400" dir="5400000">
+              <a:srgbClr val="9AA9B2">
+                <a:alpha val="35000"/>
+              </a:srgbClr>
+            </a:outerShdw>
+          </a:effectLst>
+        </p:spPr>
+      </p:sp>
+      <p:pic>
+        <p:nvPicPr>
+          <p:cNvPr id="9" name="Image 1" descr="/Users/maswiet/Work/Students/Pak_Zuhdi/figures/rf_java/vs_profiles.png">    </p:cNvPr>
+          <p:cNvPicPr>
+            <a:picLocks noChangeAspect="1"/>
+          </p:cNvPicPr>
+          <p:nvPr/>
+        </p:nvPicPr>
+        <p:blipFill>
+          <a:blip r:embed="rId2"/>
+          <a:srcRect l="0" r="0" t="0" b="0"/>
+          <a:stretch/>
+        </p:blipFill>
+        <p:spPr>
+          <a:xfrm>
+            <a:off x="7818120" y="1828800"/>
+            <a:ext cx="3657600" cy="4480560"/>
+          </a:xfrm>
+          <a:prstGeom prst="rect">
+            <a:avLst/>
+          </a:prstGeom>
+        </p:spPr>
+      </p:pic>
+      <p:sp>
+        <p:nvSpPr>
+          <p:cNvPr id="10" name="Text 6"/>
+          <p:cNvSpPr txBox="1"/>
+          <p:nvPr/>
+        </p:nvSpPr>
+        <p:spPr>
+          <a:xfrm>
+            <a:off x="7818120" y="6309360"/>
+            <a:ext cx="3657600" cy="274320"/>
+          </a:xfrm>
+          <a:prstGeom prst="rect">
+            <a:avLst/>
+          </a:prstGeom>
+          <a:noFill/>
+          <a:ln/>
+        </p:spPr>
+        <p:txBody>
+          <a:bodyPr wrap="square" lIns="0" tIns="0" rIns="0" bIns="0" rtlCol="0" anchor="ctr"/>
+          <a:lstStyle/>
+          <a:p>
+            <a:pPr algn="ctr" indent="0" marL="0">
+              <a:buNone/>
+            </a:pPr>
+            <a:r>
+              <a:rPr lang="en-US" sz="1000" i="1" dirty="0">
+                <a:solidFill>
+                  <a:srgbClr val="5A6B78"/>
+                </a:solidFill>
+                <a:latin typeface="Calibri" pitchFamily="34" charset="0"/>
+                <a:ea typeface="Calibri" pitchFamily="34" charset="-122"/>
+                <a:cs typeface="Calibri" pitchFamily="34" charset="-120"/>
+              </a:rPr>
+              <a:t>Flagship stations</a:t>
+            </a:r>
+            <a:endParaRPr lang="en-US" sz="1000" dirty="0"/>
           </a:p>
         </p:txBody>
       </p:sp>
@@ -8505,7 +8574,7 @@
                 <a:ea typeface="Calibri" pitchFamily="34" charset="-122"/>
                 <a:cs typeface="Calibri" pitchFamily="34" charset="-120"/>
               </a:rPr>
-              <a:t>RESULT  ·  SEISMOLOGY</a:t>
+              <a:t>THE EXPERIMENT</a:t>
             </a:r>
             <a:endParaRPr lang="en-US" sz="1300" dirty="0"/>
           </a:p>
@@ -8544,7 +8613,7 @@
                 <a:ea typeface="Cambria" pitchFamily="34" charset="-122"/>
                 <a:cs typeface="Cambria" pitchFamily="34" charset="-120"/>
               </a:rPr>
-              <a:t>Sediment thickness measured directly at 103 stations</a:t>
+              <a:t>MERAMEX 2004 — a dense passive array over Central Java</a:t>
             </a:r>
             <a:endParaRPr lang="en-US" sz="3000" dirty="0"/>
           </a:p>
@@ -8558,12 +8627,432 @@
         </p:nvSpPr>
         <p:spPr>
           <a:xfrm>
-            <a:off x="768096" y="1728216"/>
-            <a:ext cx="6876288" cy="4681728"/>
+            <a:off x="822960" y="1828800"/>
+            <a:ext cx="2606040" cy="1554480"/>
           </a:xfrm>
           <a:prstGeom prst="roundRect">
             <a:avLst>
-              <a:gd name="adj" fmla="val 1172"/>
+              <a:gd name="adj" fmla="val 4706"/>
+            </a:avLst>
+          </a:prstGeom>
+          <a:solidFill>
+            <a:srgbClr val="EEF3F6"/>
+          </a:solidFill>
+          <a:ln w="12700">
+            <a:solidFill>
+              <a:srgbClr val="DCE6EB"/>
+            </a:solidFill>
+            <a:prstDash val="solid"/>
+          </a:ln>
+        </p:spPr>
+      </p:sp>
+      <p:sp>
+        <p:nvSpPr>
+          <p:cNvPr id="6" name="Text 4"/>
+          <p:cNvSpPr txBox="1"/>
+          <p:nvPr/>
+        </p:nvSpPr>
+        <p:spPr>
+          <a:xfrm>
+            <a:off x="914400" y="2011680"/>
+            <a:ext cx="2423160" cy="731520"/>
+          </a:xfrm>
+          <a:prstGeom prst="rect">
+            <a:avLst/>
+          </a:prstGeom>
+          <a:noFill/>
+          <a:ln/>
+        </p:spPr>
+        <p:txBody>
+          <a:bodyPr wrap="square" lIns="0" tIns="0" rIns="0" bIns="0" rtlCol="0" anchor="ctr"/>
+          <a:lstStyle/>
+          <a:p>
+            <a:pPr algn="ctr" indent="0" marL="0">
+              <a:buNone/>
+            </a:pPr>
+            <a:r>
+              <a:rPr lang="en-US" sz="3400" b="1" dirty="0">
+                <a:solidFill>
+                  <a:srgbClr val="065A82"/>
+                </a:solidFill>
+                <a:latin typeface="Cambria" pitchFamily="34" charset="0"/>
+                <a:ea typeface="Cambria" pitchFamily="34" charset="-122"/>
+                <a:cs typeface="Cambria" pitchFamily="34" charset="-120"/>
+              </a:rPr>
+              <a:t>143</a:t>
+            </a:r>
+            <a:endParaRPr lang="en-US" sz="3400" dirty="0"/>
+          </a:p>
+        </p:txBody>
+      </p:sp>
+      <p:sp>
+        <p:nvSpPr>
+          <p:cNvPr id="7" name="Text 5"/>
+          <p:cNvSpPr txBox="1"/>
+          <p:nvPr/>
+        </p:nvSpPr>
+        <p:spPr>
+          <a:xfrm>
+            <a:off x="914400" y="2788920"/>
+            <a:ext cx="2423160" cy="457200"/>
+          </a:xfrm>
+          <a:prstGeom prst="rect">
+            <a:avLst/>
+          </a:prstGeom>
+          <a:noFill/>
+          <a:ln/>
+        </p:spPr>
+        <p:txBody>
+          <a:bodyPr wrap="square" lIns="0" tIns="0" rIns="0" bIns="0" rtlCol="0" anchor="ctr"/>
+          <a:lstStyle/>
+          <a:p>
+            <a:pPr algn="ctr" indent="0" marL="0">
+              <a:buNone/>
+            </a:pPr>
+            <a:r>
+              <a:rPr lang="en-US" sz="1300" dirty="0">
+                <a:solidFill>
+                  <a:srgbClr val="5A6B78"/>
+                </a:solidFill>
+                <a:latin typeface="Calibri" pitchFamily="34" charset="0"/>
+                <a:ea typeface="Calibri" pitchFamily="34" charset="-122"/>
+                <a:cs typeface="Calibri" pitchFamily="34" charset="-120"/>
+              </a:rPr>
+              <a:t>seismic stations</a:t>
+            </a:r>
+            <a:endParaRPr lang="en-US" sz="1300" dirty="0"/>
+          </a:p>
+        </p:txBody>
+      </p:sp>
+      <p:sp>
+        <p:nvSpPr>
+          <p:cNvPr id="8" name="Shape 6"/>
+          <p:cNvSpPr/>
+          <p:nvPr/>
+        </p:nvSpPr>
+        <p:spPr>
+          <a:xfrm>
+            <a:off x="3611880" y="1828800"/>
+            <a:ext cx="2606040" cy="1554480"/>
+          </a:xfrm>
+          <a:prstGeom prst="roundRect">
+            <a:avLst>
+              <a:gd name="adj" fmla="val 4706"/>
+            </a:avLst>
+          </a:prstGeom>
+          <a:solidFill>
+            <a:srgbClr val="EEF3F6"/>
+          </a:solidFill>
+          <a:ln w="12700">
+            <a:solidFill>
+              <a:srgbClr val="DCE6EB"/>
+            </a:solidFill>
+            <a:prstDash val="solid"/>
+          </a:ln>
+        </p:spPr>
+      </p:sp>
+      <p:sp>
+        <p:nvSpPr>
+          <p:cNvPr id="9" name="Text 7"/>
+          <p:cNvSpPr txBox="1"/>
+          <p:nvPr/>
+        </p:nvSpPr>
+        <p:spPr>
+          <a:xfrm>
+            <a:off x="3703320" y="2011680"/>
+            <a:ext cx="2423160" cy="731520"/>
+          </a:xfrm>
+          <a:prstGeom prst="rect">
+            <a:avLst/>
+          </a:prstGeom>
+          <a:noFill/>
+          <a:ln/>
+        </p:spPr>
+        <p:txBody>
+          <a:bodyPr wrap="square" lIns="0" tIns="0" rIns="0" bIns="0" rtlCol="0" anchor="ctr"/>
+          <a:lstStyle/>
+          <a:p>
+            <a:pPr algn="ctr" indent="0" marL="0">
+              <a:buNone/>
+            </a:pPr>
+            <a:r>
+              <a:rPr lang="en-US" sz="3400" b="1" dirty="0">
+                <a:solidFill>
+                  <a:srgbClr val="065A82"/>
+                </a:solidFill>
+                <a:latin typeface="Cambria" pitchFamily="34" charset="0"/>
+                <a:ea typeface="Cambria" pitchFamily="34" charset="-122"/>
+                <a:cs typeface="Cambria" pitchFamily="34" charset="-120"/>
+              </a:rPr>
+              <a:t>110</a:t>
+            </a:r>
+            <a:endParaRPr lang="en-US" sz="3400" dirty="0"/>
+          </a:p>
+        </p:txBody>
+      </p:sp>
+      <p:sp>
+        <p:nvSpPr>
+          <p:cNvPr id="10" name="Text 8"/>
+          <p:cNvSpPr txBox="1"/>
+          <p:nvPr/>
+        </p:nvSpPr>
+        <p:spPr>
+          <a:xfrm>
+            <a:off x="3703320" y="2788920"/>
+            <a:ext cx="2423160" cy="457200"/>
+          </a:xfrm>
+          <a:prstGeom prst="rect">
+            <a:avLst/>
+          </a:prstGeom>
+          <a:noFill/>
+          <a:ln/>
+        </p:spPr>
+        <p:txBody>
+          <a:bodyPr wrap="square" lIns="0" tIns="0" rIns="0" bIns="0" rtlCol="0" anchor="ctr"/>
+          <a:lstStyle/>
+          <a:p>
+            <a:pPr algn="ctr" indent="0" marL="0">
+              <a:buNone/>
+            </a:pPr>
+            <a:r>
+              <a:rPr lang="en-US" sz="1300" dirty="0">
+                <a:solidFill>
+                  <a:srgbClr val="5A6B78"/>
+                </a:solidFill>
+                <a:latin typeface="Calibri" pitchFamily="34" charset="0"/>
+                <a:ea typeface="Calibri" pitchFamily="34" charset="-122"/>
+                <a:cs typeface="Calibri" pitchFamily="34" charset="-120"/>
+              </a:rPr>
+              <a:t>stations with RFs</a:t>
+            </a:r>
+            <a:endParaRPr lang="en-US" sz="1300" dirty="0"/>
+          </a:p>
+        </p:txBody>
+      </p:sp>
+      <p:sp>
+        <p:nvSpPr>
+          <p:cNvPr id="11" name="Shape 9"/>
+          <p:cNvSpPr/>
+          <p:nvPr/>
+        </p:nvSpPr>
+        <p:spPr>
+          <a:xfrm>
+            <a:off x="6400800" y="1828800"/>
+            <a:ext cx="2606040" cy="1554480"/>
+          </a:xfrm>
+          <a:prstGeom prst="roundRect">
+            <a:avLst>
+              <a:gd name="adj" fmla="val 4706"/>
+            </a:avLst>
+          </a:prstGeom>
+          <a:solidFill>
+            <a:srgbClr val="EEF3F6"/>
+          </a:solidFill>
+          <a:ln w="12700">
+            <a:solidFill>
+              <a:srgbClr val="DCE6EB"/>
+            </a:solidFill>
+            <a:prstDash val="solid"/>
+          </a:ln>
+        </p:spPr>
+      </p:sp>
+      <p:sp>
+        <p:nvSpPr>
+          <p:cNvPr id="12" name="Text 10"/>
+          <p:cNvSpPr txBox="1"/>
+          <p:nvPr/>
+        </p:nvSpPr>
+        <p:spPr>
+          <a:xfrm>
+            <a:off x="6492240" y="2011680"/>
+            <a:ext cx="2423160" cy="731520"/>
+          </a:xfrm>
+          <a:prstGeom prst="rect">
+            <a:avLst/>
+          </a:prstGeom>
+          <a:noFill/>
+          <a:ln/>
+        </p:spPr>
+        <p:txBody>
+          <a:bodyPr wrap="square" lIns="0" tIns="0" rIns="0" bIns="0" rtlCol="0" anchor="ctr"/>
+          <a:lstStyle/>
+          <a:p>
+            <a:pPr algn="ctr" indent="0" marL="0">
+              <a:buNone/>
+            </a:pPr>
+            <a:r>
+              <a:rPr lang="en-US" sz="3400" b="1" dirty="0">
+                <a:solidFill>
+                  <a:srgbClr val="065A82"/>
+                </a:solidFill>
+                <a:latin typeface="Cambria" pitchFamily="34" charset="0"/>
+                <a:ea typeface="Cambria" pitchFamily="34" charset="-122"/>
+                <a:cs typeface="Cambria" pitchFamily="34" charset="-120"/>
+              </a:rPr>
+              <a:t>7</a:t>
+            </a:r>
+            <a:endParaRPr lang="en-US" sz="3400" dirty="0"/>
+          </a:p>
+        </p:txBody>
+      </p:sp>
+      <p:sp>
+        <p:nvSpPr>
+          <p:cNvPr id="13" name="Text 11"/>
+          <p:cNvSpPr txBox="1"/>
+          <p:nvPr/>
+        </p:nvSpPr>
+        <p:spPr>
+          <a:xfrm>
+            <a:off x="6492240" y="2788920"/>
+            <a:ext cx="2423160" cy="457200"/>
+          </a:xfrm>
+          <a:prstGeom prst="rect">
+            <a:avLst/>
+          </a:prstGeom>
+          <a:noFill/>
+          <a:ln/>
+        </p:spPr>
+        <p:txBody>
+          <a:bodyPr wrap="square" lIns="0" tIns="0" rIns="0" bIns="0" rtlCol="0" anchor="ctr"/>
+          <a:lstStyle/>
+          <a:p>
+            <a:pPr algn="ctr" indent="0" marL="0">
+              <a:buNone/>
+            </a:pPr>
+            <a:r>
+              <a:rPr lang="en-US" sz="1300" dirty="0">
+                <a:solidFill>
+                  <a:srgbClr val="5A6B78"/>
+                </a:solidFill>
+                <a:latin typeface="Calibri" pitchFamily="34" charset="0"/>
+                <a:ea typeface="Calibri" pitchFamily="34" charset="-122"/>
+                <a:cs typeface="Calibri" pitchFamily="34" charset="-120"/>
+              </a:rPr>
+              <a:t>teleseisms used</a:t>
+            </a:r>
+            <a:endParaRPr lang="en-US" sz="1300" dirty="0"/>
+          </a:p>
+        </p:txBody>
+      </p:sp>
+      <p:sp>
+        <p:nvSpPr>
+          <p:cNvPr id="14" name="Shape 12"/>
+          <p:cNvSpPr/>
+          <p:nvPr/>
+        </p:nvSpPr>
+        <p:spPr>
+          <a:xfrm>
+            <a:off x="9189720" y="1828800"/>
+            <a:ext cx="2606040" cy="1554480"/>
+          </a:xfrm>
+          <a:prstGeom prst="roundRect">
+            <a:avLst>
+              <a:gd name="adj" fmla="val 4706"/>
+            </a:avLst>
+          </a:prstGeom>
+          <a:solidFill>
+            <a:srgbClr val="EEF3F6"/>
+          </a:solidFill>
+          <a:ln w="12700">
+            <a:solidFill>
+              <a:srgbClr val="DCE6EB"/>
+            </a:solidFill>
+            <a:prstDash val="solid"/>
+          </a:ln>
+        </p:spPr>
+      </p:sp>
+      <p:sp>
+        <p:nvSpPr>
+          <p:cNvPr id="15" name="Text 13"/>
+          <p:cNvSpPr txBox="1"/>
+          <p:nvPr/>
+        </p:nvSpPr>
+        <p:spPr>
+          <a:xfrm>
+            <a:off x="9281160" y="2011680"/>
+            <a:ext cx="2423160" cy="731520"/>
+          </a:xfrm>
+          <a:prstGeom prst="rect">
+            <a:avLst/>
+          </a:prstGeom>
+          <a:noFill/>
+          <a:ln/>
+        </p:spPr>
+        <p:txBody>
+          <a:bodyPr wrap="square" lIns="0" tIns="0" rIns="0" bIns="0" rtlCol="0" anchor="ctr"/>
+          <a:lstStyle/>
+          <a:p>
+            <a:pPr algn="ctr" indent="0" marL="0">
+              <a:buNone/>
+            </a:pPr>
+            <a:r>
+              <a:rPr lang="en-US" sz="3400" b="1" dirty="0">
+                <a:solidFill>
+                  <a:srgbClr val="065A82"/>
+                </a:solidFill>
+                <a:latin typeface="Cambria" pitchFamily="34" charset="0"/>
+                <a:ea typeface="Cambria" pitchFamily="34" charset="-122"/>
+                <a:cs typeface="Cambria" pitchFamily="34" charset="-120"/>
+              </a:rPr>
+              <a:t>~2.8 km</a:t>
+            </a:r>
+            <a:endParaRPr lang="en-US" sz="3400" dirty="0"/>
+          </a:p>
+        </p:txBody>
+      </p:sp>
+      <p:sp>
+        <p:nvSpPr>
+          <p:cNvPr id="16" name="Text 14"/>
+          <p:cNvSpPr txBox="1"/>
+          <p:nvPr/>
+        </p:nvSpPr>
+        <p:spPr>
+          <a:xfrm>
+            <a:off x="9281160" y="2788920"/>
+            <a:ext cx="2423160" cy="457200"/>
+          </a:xfrm>
+          <a:prstGeom prst="rect">
+            <a:avLst/>
+          </a:prstGeom>
+          <a:noFill/>
+          <a:ln/>
+        </p:spPr>
+        <p:txBody>
+          <a:bodyPr wrap="square" lIns="0" tIns="0" rIns="0" bIns="0" rtlCol="0" anchor="ctr"/>
+          <a:lstStyle/>
+          <a:p>
+            <a:pPr algn="ctr" indent="0" marL="0">
+              <a:buNone/>
+            </a:pPr>
+            <a:r>
+              <a:rPr lang="en-US" sz="1300" dirty="0">
+                <a:solidFill>
+                  <a:srgbClr val="5A6B78"/>
+                </a:solidFill>
+                <a:latin typeface="Calibri" pitchFamily="34" charset="0"/>
+                <a:ea typeface="Calibri" pitchFamily="34" charset="-122"/>
+                <a:cs typeface="Calibri" pitchFamily="34" charset="-120"/>
+              </a:rPr>
+              <a:t>median sediment</a:t>
+            </a:r>
+            <a:endParaRPr lang="en-US" sz="1300" dirty="0"/>
+          </a:p>
+        </p:txBody>
+      </p:sp>
+      <p:sp>
+        <p:nvSpPr>
+          <p:cNvPr id="17" name="Shape 15"/>
+          <p:cNvSpPr/>
+          <p:nvPr/>
+        </p:nvSpPr>
+        <p:spPr>
+          <a:xfrm>
+            <a:off x="3054096" y="3557016"/>
+            <a:ext cx="6053328" cy="3035808"/>
+          </a:xfrm>
+          <a:prstGeom prst="roundRect">
+            <a:avLst>
+              <a:gd name="adj" fmla="val 1807"/>
             </a:avLst>
           </a:prstGeom>
           <a:solidFill>
@@ -8586,7 +9075,7 @@
       </p:sp>
       <p:pic>
         <p:nvPicPr>
-          <p:cNvPr id="6" name="Image 0" descr="/Users/maswiet/Work/Students/Pak_Zuhdi/figures/rf_java/sediment_rf_map.png">    </p:cNvPr>
+          <p:cNvPr id="18" name="Image 0" descr="/Users/maswiet/Work/Students/Pak_Zuhdi/figures/rf_java/sediment_rf_map.png">    </p:cNvPr>
           <p:cNvPicPr>
             <a:picLocks noChangeAspect="1"/>
           </p:cNvPicPr>
@@ -8599,8 +9088,8 @@
         </p:blipFill>
         <p:spPr>
           <a:xfrm>
-            <a:off x="822960" y="1783080"/>
-            <a:ext cx="6766560" cy="4572000"/>
+            <a:off x="3108960" y="3611880"/>
+            <a:ext cx="5943600" cy="2926080"/>
           </a:xfrm>
           <a:prstGeom prst="rect">
             <a:avLst/>
@@ -8609,53 +9098,14 @@
       </p:pic>
       <p:sp>
         <p:nvSpPr>
-          <p:cNvPr id="7" name="Text 4"/>
-          <p:cNvSpPr txBox="1"/>
-          <p:nvPr/>
-        </p:nvSpPr>
-        <p:spPr>
-          <a:xfrm>
-            <a:off x="7863840" y="1920240"/>
-            <a:ext cx="3657600" cy="365760"/>
-          </a:xfrm>
-          <a:prstGeom prst="rect">
-            <a:avLst/>
-          </a:prstGeom>
-          <a:noFill/>
-          <a:ln/>
-        </p:spPr>
-        <p:txBody>
-          <a:bodyPr wrap="square" lIns="0" tIns="0" rIns="0" bIns="0" rtlCol="0" anchor="ctr"/>
-          <a:lstStyle/>
-          <a:p>
-            <a:pPr indent="0" marL="0">
-              <a:buNone/>
-            </a:pPr>
-            <a:r>
-              <a:rPr lang="en-US" sz="1700" b="1" dirty="0">
-                <a:solidFill>
-                  <a:srgbClr val="1C7293"/>
-                </a:solidFill>
-                <a:latin typeface="Calibri" pitchFamily="34" charset="0"/>
-                <a:ea typeface="Calibri" pitchFamily="34" charset="-122"/>
-                <a:cs typeface="Calibri" pitchFamily="34" charset="-120"/>
-              </a:rPr>
-              <a:t>What the RFs say</a:t>
-            </a:r>
-            <a:endParaRPr lang="en-US" sz="1700" dirty="0"/>
-          </a:p>
-        </p:txBody>
-      </p:sp>
-      <p:sp>
-        <p:nvSpPr>
-          <p:cNvPr id="8" name="Text 5"/>
-          <p:cNvSpPr txBox="1"/>
-          <p:nvPr/>
-        </p:nvSpPr>
-        <p:spPr>
-          <a:xfrm>
-            <a:off x="7863840" y="2331720"/>
-            <a:ext cx="3749040" cy="2926080"/>
+          <p:cNvPr id="19" name="Text 16"/>
+          <p:cNvSpPr txBox="1"/>
+          <p:nvPr/>
+        </p:nvSpPr>
+        <p:spPr>
+          <a:xfrm>
+            <a:off x="822960" y="3703320"/>
+            <a:ext cx="2194560" cy="2743200"/>
           </a:xfrm>
           <a:prstGeom prst="rect">
             <a:avLst/>
@@ -8669,16 +9119,16 @@
           <a:p>
             <a:pPr marL="342900" indent="-342900">
               <a:lnSpc>
-                <a:spcPct val="110000"/>
+                <a:spcPct val="105000"/>
               </a:lnSpc>
               <a:spcAft>
-                <a:spcPts val="1100"/>
+                <a:spcPts val="900"/>
               </a:spcAft>
               <a:buSzPct val="100000"/>
               <a:buChar char="•"/>
             </a:pPr>
             <a:r>
-              <a:rPr lang="en-US" sz="1500" dirty="0">
+              <a:rPr lang="en-US" sz="1300" dirty="0">
                 <a:solidFill>
                   <a:srgbClr val="10233A"/>
                 </a:solidFill>
@@ -8686,23 +9136,23 @@
                 <a:ea typeface="Calibri" pitchFamily="34" charset="-122"/>
                 <a:cs typeface="Calibri" pitchFamily="34" charset="-120"/>
               </a:rPr>
-              <a:t>Median ~2.8 km; range 0.9–7.2 km.</a:t>
-            </a:r>
-            <a:endParaRPr lang="en-US" sz="1500" dirty="0"/>
+              <a:t>Merapi Amphibious Experiment (GFZ), May–Oct 2004.</a:t>
+            </a:r>
+            <a:endParaRPr lang="en-US" sz="1300" dirty="0"/>
           </a:p>
           <a:p>
             <a:pPr marL="342900" indent="-342900">
               <a:lnSpc>
-                <a:spcPct val="110000"/>
+                <a:spcPct val="105000"/>
               </a:lnSpc>
               <a:spcAft>
-                <a:spcPts val="1100"/>
+                <a:spcPts val="900"/>
               </a:spcAft>
               <a:buSzPct val="100000"/>
               <a:buChar char="•"/>
             </a:pPr>
             <a:r>
-              <a:rPr lang="en-US" sz="1500" dirty="0">
+              <a:rPr lang="en-US" sz="1300" dirty="0">
                 <a:solidFill>
                   <a:srgbClr val="10233A"/>
                 </a:solidFill>
@@ -8710,23 +9160,23 @@
                 <a:ea typeface="Calibri" pitchFamily="34" charset="-122"/>
                 <a:cs typeface="Calibri" pitchFamily="34" charset="-120"/>
               </a:rPr>
-              <a:t>Consistent with published Central-Java basin depths.</a:t>
-            </a:r>
-            <a:endParaRPr lang="en-US" sz="1500" dirty="0"/>
+              <a:t>Broadband + short-period stations, ~10–20 km spacing.</a:t>
+            </a:r>
+            <a:endParaRPr lang="en-US" sz="1300" dirty="0"/>
           </a:p>
           <a:p>
             <a:pPr marL="342900" indent="-342900">
               <a:lnSpc>
-                <a:spcPct val="110000"/>
+                <a:spcPct val="105000"/>
               </a:lnSpc>
               <a:spcAft>
-                <a:spcPts val="1100"/>
+                <a:spcPts val="900"/>
               </a:spcAft>
               <a:buSzPct val="100000"/>
               <a:buChar char="•"/>
             </a:pPr>
             <a:r>
-              <a:rPr lang="en-US" sz="1500" dirty="0">
+              <a:rPr lang="en-US" sz="1300" dirty="0">
                 <a:solidFill>
                   <a:srgbClr val="10233A"/>
                 </a:solidFill>
@@ -8734,23 +9184,23 @@
                 <a:ea typeface="Calibri" pitchFamily="34" charset="-122"/>
                 <a:cs typeface="Calibri" pitchFamily="34" charset="-120"/>
               </a:rPr>
-              <a:t>Thick pockets mark depocentres; thin zones mark basement/volcanic highs.</a:t>
-            </a:r>
-            <a:endParaRPr lang="en-US" sz="1500" dirty="0"/>
+              <a:t>Public / experiment data — no new acquisition.</a:t>
+            </a:r>
+            <a:endParaRPr lang="en-US" sz="1300" dirty="0"/>
           </a:p>
           <a:p>
             <a:pPr marL="342900" indent="-342900">
               <a:lnSpc>
-                <a:spcPct val="110000"/>
+                <a:spcPct val="105000"/>
               </a:lnSpc>
               <a:spcAft>
-                <a:spcPts val="1100"/>
+                <a:spcPts val="900"/>
               </a:spcAft>
               <a:buSzPct val="100000"/>
               <a:buChar char="•"/>
             </a:pPr>
             <a:r>
-              <a:rPr lang="en-US" sz="1500" dirty="0">
+              <a:rPr lang="en-US" sz="1300" dirty="0">
                 <a:solidFill>
                   <a:srgbClr val="10233A"/>
                 </a:solidFill>
@@ -8758,48 +9208,9 @@
                 <a:ea typeface="Calibri" pitchFamily="34" charset="-122"/>
                 <a:cs typeface="Calibri" pitchFamily="34" charset="-120"/>
               </a:rPr>
-              <a:t>Absolute, physical — no density assumption needed.</a:t>
-            </a:r>
-            <a:endParaRPr lang="en-US" sz="1500" dirty="0"/>
-          </a:p>
-        </p:txBody>
-      </p:sp>
-      <p:sp>
-        <p:nvSpPr>
-          <p:cNvPr id="9" name="Text 6"/>
-          <p:cNvSpPr txBox="1"/>
-          <p:nvPr/>
-        </p:nvSpPr>
-        <p:spPr>
-          <a:xfrm>
-            <a:off x="7863840" y="5486400"/>
-            <a:ext cx="3749040" cy="548640"/>
-          </a:xfrm>
-          <a:prstGeom prst="rect">
-            <a:avLst/>
-          </a:prstGeom>
-          <a:noFill/>
-          <a:ln/>
-        </p:spPr>
-        <p:txBody>
-          <a:bodyPr wrap="square" lIns="0" tIns="0" rIns="0" bIns="0" rtlCol="0" anchor="ctr"/>
-          <a:lstStyle/>
-          <a:p>
-            <a:pPr indent="0" marL="0">
-              <a:buNone/>
-            </a:pPr>
-            <a:r>
-              <a:rPr lang="en-US" sz="1800" b="1" i="1" dirty="0">
-                <a:solidFill>
-                  <a:srgbClr val="065A82"/>
-                </a:solidFill>
-                <a:latin typeface="Calibri" pitchFamily="34" charset="0"/>
-                <a:ea typeface="Calibri" pitchFamily="34" charset="-122"/>
-                <a:cs typeface="Calibri" pitchFamily="34" charset="-120"/>
-              </a:rPr>
-              <a:t>This is the anchor.</a:t>
-            </a:r>
-            <a:endParaRPr lang="en-US" sz="1800" dirty="0"/>
+              <a:t>Each dot = one RF-derived sediment estimate.</a:t>
+            </a:r>
+            <a:endParaRPr lang="en-US" sz="1300" dirty="0"/>
           </a:p>
         </p:txBody>
       </p:sp>

</xml_diff>

<commit_message>
Fix stretched figures: fit each image to its true aspect ratio
PowerPoint/Keynote ignore pptxgenjs "contain" sizing and stretched maps
to the raw box (the horizontal smearing on the Bouguer/residual/sediment
maps). figBox now reads each PNG/JPEG's intrinsic pixel size, fits the
image inside its box at the correct aspect ratio, centres it, and frames
the card tight around the fitted image — so no viewer can distort it.

Co-Authored-By: Claude Opus 4.8 <noreply@anthropic.com>
</commit_message>
<xml_diff>
--- a/pitch_rf_gravity/RF_Gravity_CentralJava_keynote.pptx
+++ b/pitch_rf_gravity/RF_Gravity_CentralJava_keynote.pptx
@@ -2883,12 +2883,12 @@
         </p:nvSpPr>
         <p:spPr>
           <a:xfrm>
-            <a:off x="768096" y="1773936"/>
-            <a:ext cx="6693408" cy="4041648"/>
+            <a:off x="768096" y="2093976"/>
+            <a:ext cx="6693408" cy="3401568"/>
           </a:xfrm>
           <a:prstGeom prst="roundRect">
             <a:avLst>
-              <a:gd name="adj" fmla="val 1357"/>
+              <a:gd name="adj" fmla="val 1613"/>
             </a:avLst>
           </a:prstGeom>
           <a:solidFill>
@@ -2919,13 +2919,14 @@
         </p:nvPicPr>
         <p:blipFill>
           <a:blip r:embed="rId1"/>
-          <a:srcRect l="0" r="0" t="0" b="0"/>
-          <a:stretch/>
+          <a:stretch>
+            <a:fillRect/>
+          </a:stretch>
         </p:blipFill>
         <p:spPr>
           <a:xfrm>
-            <a:off x="822960" y="1828800"/>
-            <a:ext cx="6583680" cy="3931920"/>
+            <a:off x="822960" y="2148840"/>
+            <a:ext cx="6583680" cy="3291840"/>
           </a:xfrm>
           <a:prstGeom prst="rect">
             <a:avLst/>
@@ -3266,12 +3267,12 @@
         </p:nvSpPr>
         <p:spPr>
           <a:xfrm>
-            <a:off x="768096" y="1773936"/>
-            <a:ext cx="6876288" cy="4041648"/>
+            <a:off x="768096" y="1785112"/>
+            <a:ext cx="6876288" cy="4019296"/>
           </a:xfrm>
           <a:prstGeom prst="roundRect">
             <a:avLst>
-              <a:gd name="adj" fmla="val 1357"/>
+              <a:gd name="adj" fmla="val 1365"/>
             </a:avLst>
           </a:prstGeom>
           <a:solidFill>
@@ -3302,13 +3303,14 @@
         </p:nvPicPr>
         <p:blipFill>
           <a:blip r:embed="rId1"/>
-          <a:srcRect l="0" r="0" t="0" b="0"/>
-          <a:stretch/>
+          <a:stretch>
+            <a:fillRect/>
+          </a:stretch>
         </p:blipFill>
         <p:spPr>
           <a:xfrm>
-            <a:off x="822960" y="1828800"/>
-            <a:ext cx="6766560" cy="3931920"/>
+            <a:off x="822960" y="1839976"/>
+            <a:ext cx="6766560" cy="3909568"/>
           </a:xfrm>
           <a:prstGeom prst="rect">
             <a:avLst/>
@@ -3362,8 +3364,8 @@
         </p:nvSpPr>
         <p:spPr>
           <a:xfrm>
-            <a:off x="7763256" y="1773936"/>
-            <a:ext cx="3767328" cy="4590288"/>
+            <a:off x="7763256" y="1852907"/>
+            <a:ext cx="3767328" cy="4432346"/>
           </a:xfrm>
           <a:prstGeom prst="roundRect">
             <a:avLst>
@@ -3398,13 +3400,14 @@
         </p:nvPicPr>
         <p:blipFill>
           <a:blip r:embed="rId2"/>
-          <a:srcRect l="0" r="0" t="0" b="0"/>
-          <a:stretch/>
+          <a:stretch>
+            <a:fillRect/>
+          </a:stretch>
         </p:blipFill>
         <p:spPr>
           <a:xfrm>
-            <a:off x="7818120" y="1828800"/>
-            <a:ext cx="3657600" cy="4480560"/>
+            <a:off x="7818120" y="1907771"/>
+            <a:ext cx="3657600" cy="4322618"/>
           </a:xfrm>
           <a:prstGeom prst="rect">
             <a:avLst/>
@@ -4561,12 +4564,12 @@
         </p:nvSpPr>
         <p:spPr>
           <a:xfrm>
-            <a:off x="3328416" y="3557016"/>
-            <a:ext cx="5504688" cy="3035808"/>
+            <a:off x="4853513" y="3557016"/>
+            <a:ext cx="2454493" cy="3035808"/>
           </a:xfrm>
           <a:prstGeom prst="roundRect">
             <a:avLst>
-              <a:gd name="adj" fmla="val 1807"/>
+              <a:gd name="adj" fmla="val 2235"/>
             </a:avLst>
           </a:prstGeom>
           <a:solidFill>
@@ -4597,13 +4600,14 @@
         </p:nvPicPr>
         <p:blipFill>
           <a:blip r:embed="rId1"/>
-          <a:srcRect l="0" r="0" t="0" b="0"/>
-          <a:stretch/>
+          <a:stretch>
+            <a:fillRect/>
+          </a:stretch>
         </p:blipFill>
         <p:spPr>
           <a:xfrm>
-            <a:off x="3383280" y="3611880"/>
-            <a:ext cx="5394960" cy="2926080"/>
+            <a:off x="4908377" y="3611880"/>
+            <a:ext cx="2344765" cy="2926080"/>
           </a:xfrm>
           <a:prstGeom prst="rect">
             <a:avLst/>
@@ -4854,12 +4858,12 @@
         </p:nvSpPr>
         <p:spPr>
           <a:xfrm>
-            <a:off x="768096" y="1682496"/>
-            <a:ext cx="6876288" cy="4681728"/>
+            <a:off x="2319528" y="1682496"/>
+            <a:ext cx="3773424" cy="4681728"/>
           </a:xfrm>
           <a:prstGeom prst="roundRect">
             <a:avLst>
-              <a:gd name="adj" fmla="val 1172"/>
+              <a:gd name="adj" fmla="val 1454"/>
             </a:avLst>
           </a:prstGeom>
           <a:solidFill>
@@ -4890,13 +4894,14 @@
         </p:nvPicPr>
         <p:blipFill>
           <a:blip r:embed="rId1"/>
-          <a:srcRect l="0" r="0" t="0" b="0"/>
-          <a:stretch/>
+          <a:stretch>
+            <a:fillRect/>
+          </a:stretch>
         </p:blipFill>
         <p:spPr>
           <a:xfrm>
-            <a:off x="822960" y="1737360"/>
-            <a:ext cx="6766560" cy="4572000"/>
+            <a:off x="2374392" y="1737360"/>
+            <a:ext cx="3663696" cy="4572000"/>
           </a:xfrm>
           <a:prstGeom prst="rect">
             <a:avLst/>
@@ -5213,12 +5218,12 @@
         </p:nvSpPr>
         <p:spPr>
           <a:xfrm>
-            <a:off x="768096" y="1773936"/>
-            <a:ext cx="5321808" cy="4224528"/>
+            <a:off x="1378713" y="1773936"/>
+            <a:ext cx="4100575" cy="4224528"/>
           </a:xfrm>
           <a:prstGeom prst="roundRect">
             <a:avLst>
-              <a:gd name="adj" fmla="val 1299"/>
+              <a:gd name="adj" fmla="val 1338"/>
             </a:avLst>
           </a:prstGeom>
           <a:solidFill>
@@ -5249,13 +5254,14 @@
         </p:nvPicPr>
         <p:blipFill>
           <a:blip r:embed="rId1"/>
-          <a:srcRect l="0" r="0" t="0" b="0"/>
-          <a:stretch/>
+          <a:stretch>
+            <a:fillRect/>
+          </a:stretch>
         </p:blipFill>
         <p:spPr>
           <a:xfrm>
-            <a:off x="822960" y="1828800"/>
-            <a:ext cx="5212080" cy="4114800"/>
+            <a:off x="1433577" y="1828800"/>
+            <a:ext cx="3990847" cy="4114800"/>
           </a:xfrm>
           <a:prstGeom prst="rect">
             <a:avLst/>
@@ -5270,12 +5276,12 @@
         </p:nvSpPr>
         <p:spPr>
           <a:xfrm>
-            <a:off x="6117336" y="1773936"/>
-            <a:ext cx="5321808" cy="4224528"/>
+            <a:off x="6727953" y="1773936"/>
+            <a:ext cx="4100575" cy="4224528"/>
           </a:xfrm>
           <a:prstGeom prst="roundRect">
             <a:avLst>
-              <a:gd name="adj" fmla="val 1299"/>
+              <a:gd name="adj" fmla="val 1338"/>
             </a:avLst>
           </a:prstGeom>
           <a:solidFill>
@@ -5306,13 +5312,14 @@
         </p:nvPicPr>
         <p:blipFill>
           <a:blip r:embed="rId2"/>
-          <a:srcRect l="0" r="0" t="0" b="0"/>
-          <a:stretch/>
+          <a:stretch>
+            <a:fillRect/>
+          </a:stretch>
         </p:blipFill>
         <p:spPr>
           <a:xfrm>
-            <a:off x="6172200" y="1828800"/>
-            <a:ext cx="5212080" cy="4114800"/>
+            <a:off x="6782817" y="1828800"/>
+            <a:ext cx="3990847" cy="4114800"/>
           </a:xfrm>
           <a:prstGeom prst="rect">
             <a:avLst/>
@@ -5535,12 +5542,12 @@
         </p:nvSpPr>
         <p:spPr>
           <a:xfrm>
-            <a:off x="768096" y="1819656"/>
-            <a:ext cx="4864608" cy="4224528"/>
+            <a:off x="768096" y="1895856"/>
+            <a:ext cx="4864608" cy="4072128"/>
           </a:xfrm>
           <a:prstGeom prst="roundRect">
             <a:avLst>
-              <a:gd name="adj" fmla="val 1299"/>
+              <a:gd name="adj" fmla="val 1347"/>
             </a:avLst>
           </a:prstGeom>
           <a:solidFill>
@@ -5571,13 +5578,14 @@
         </p:nvPicPr>
         <p:blipFill>
           <a:blip r:embed="rId1"/>
-          <a:srcRect l="0" r="0" t="0" b="0"/>
-          <a:stretch/>
+          <a:stretch>
+            <a:fillRect/>
+          </a:stretch>
         </p:blipFill>
         <p:spPr>
           <a:xfrm>
-            <a:off x="822960" y="1874520"/>
-            <a:ext cx="4754880" cy="4114800"/>
+            <a:off x="822960" y="1950720"/>
+            <a:ext cx="4754880" cy="3962400"/>
           </a:xfrm>
           <a:prstGeom prst="rect">
             <a:avLst/>
@@ -5901,8 +5909,8 @@
         </p:nvSpPr>
         <p:spPr>
           <a:xfrm>
-            <a:off x="768096" y="1728216"/>
-            <a:ext cx="6693408" cy="4681728"/>
+            <a:off x="1772706" y="1728216"/>
+            <a:ext cx="4684189" cy="4681728"/>
           </a:xfrm>
           <a:prstGeom prst="roundRect">
             <a:avLst>
@@ -5937,13 +5945,14 @@
         </p:nvPicPr>
         <p:blipFill>
           <a:blip r:embed="rId1"/>
-          <a:srcRect l="0" r="0" t="0" b="0"/>
-          <a:stretch/>
+          <a:stretch>
+            <a:fillRect/>
+          </a:stretch>
         </p:blipFill>
         <p:spPr>
           <a:xfrm>
-            <a:off x="822960" y="1783080"/>
-            <a:ext cx="6583680" cy="4572000"/>
+            <a:off x="1827570" y="1783080"/>
+            <a:ext cx="4574461" cy="4572000"/>
           </a:xfrm>
           <a:prstGeom prst="rect">
             <a:avLst/>
@@ -10947,12 +10956,12 @@
         </p:nvSpPr>
         <p:spPr>
           <a:xfrm>
-            <a:off x="6986016" y="1728216"/>
-            <a:ext cx="4590288" cy="4590288"/>
+            <a:off x="7266051" y="1728216"/>
+            <a:ext cx="4030218" cy="4590288"/>
           </a:xfrm>
           <a:prstGeom prst="roundRect">
             <a:avLst>
-              <a:gd name="adj" fmla="val 1195"/>
+              <a:gd name="adj" fmla="val 1361"/>
             </a:avLst>
           </a:prstGeom>
           <a:solidFill>
@@ -10983,13 +10992,14 @@
         </p:nvPicPr>
         <p:blipFill>
           <a:blip r:embed="rId1"/>
-          <a:srcRect l="0" r="0" t="0" b="0"/>
-          <a:stretch/>
+          <a:stretch>
+            <a:fillRect/>
+          </a:stretch>
         </p:blipFill>
         <p:spPr>
           <a:xfrm>
-            <a:off x="7040880" y="1783080"/>
-            <a:ext cx="4480560" cy="4480560"/>
+            <a:off x="7320915" y="1783080"/>
+            <a:ext cx="3920490" cy="4480560"/>
           </a:xfrm>
           <a:prstGeom prst="rect">
             <a:avLst/>

</xml_diff>